<commit_message>
docs (#164): Add the second survey wave
Include the 4 answers of 30 October 2026 (friends of Tiago) as a
separate wave: n = 24, Q6 average 3.29 (wave 1 3.7, wave 2 1.25).
V2 stays not met and is read as open; both waves are reported and the
recruitment and answering-away-from-the-event limits are stated.

Co-Authored-By: Claude Opus 5.5 <noreply@anthropic.com>
</commit_message>
<xml_diff>
--- a/Docs/Presentation/Farol_Sprint_A_Presentation.pptx
+++ b/Docs/Presentation/Farol_Sprint_A_Presentation.pptx
@@ -124,12 +124,12 @@
   <p:extLst>
     <p:ext uri="{521415D9-36F7-43E2-AB2F-B90AF26B5E84}">
       <p14:sectionLst xmlns:p14="http://schemas.microsoft.com/office/powerpoint/2010/main">
-        <p14:section name="Opening" id="{2405d483-2e58-5d62-75ff-a3ef21ca3076}">
+        <p14:section name="Opening" id="{dd3e3070-a4ec-3fee-245e-0181f093dc6b}">
           <p14:sldIdLst>
             <p14:sldId id="256"/>
           </p14:sldIdLst>
         </p14:section>
-        <p14:section name="Product" id="{48a41275-f54c-a4ea-058b-56690407b0f6}">
+        <p14:section name="Product" id="{98e0ec4e-7d94-8ea3-3324-86e01e7e4837}">
           <p14:sldIdLst>
             <p14:sldId id="257"/>
             <p14:sldId id="258"/>
@@ -138,7 +138,7 @@
             <p14:sldId id="261"/>
           </p14:sldIdLst>
         </p14:section>
-        <p14:section name="Design" id="{29ad854f-5b23-2bb0-84f7-a7267bc2bc69}">
+        <p14:section name="Design" id="{9f0186b3-7f19-0d3c-49d8-f6a014fc6eaf}">
           <p14:sldIdLst>
             <p14:sldId id="262"/>
             <p14:sldId id="263"/>
@@ -146,7 +146,7 @@
             <p14:sldId id="265"/>
           </p14:sldIdLst>
         </p14:section>
-        <p14:section name="Plan" id="{ace32686-c9fe-d4a4-1e1c-1f5f42393875}">
+        <p14:section name="Plan" id="{985a0404-c17e-c65f-0cf9-6bb18568a3f5}">
           <p14:sldIdLst>
             <p14:sldId id="266"/>
             <p14:sldId id="267"/>
@@ -154,14 +154,14 @@
             <p14:sldId id="269"/>
           </p14:sldIdLst>
         </p14:section>
-        <p14:section name="Team" id="{e782008c-09b8-d2b1-02f4-a34e9cd86e75}">
+        <p14:section name="Team" id="{23420e0b-593c-0179-c669-648405219c49}">
           <p14:sldIdLst>
             <p14:sldId id="270"/>
             <p14:sldId id="271"/>
             <p14:sldId id="272"/>
           </p14:sldIdLst>
         </p14:section>
-        <p14:section name="Closing" id="{4f9afdcd-2ea5-f84e-22dd-6accf86f547c}">
+        <p14:section name="Closing" id="{73a94d4d-1964-fec1-bc2a-86158ef645d3}">
           <p14:sldIdLst>
             <p14:sldId id="273"/>
           </p14:sldIdLst>
@@ -201,7 +201,7 @@
                 </a:solidFill>
                 <a:latin typeface="+mn-lt"/>
               </a:rPr>
-              <a:t>Most useful features (% of 20, up to 3 each)</a:t>
+              <a:t>Most useful features (% of 24, up to 3 each)</a:t>
             </a:r>
           </a:p>
         </c:rich>
@@ -274,10 +274,10 @@
                     <c:v>Transport home</c:v>
                   </c:pt>
                   <c:pt idx="2">
-                    <c:v>Wait time at entrances</c:v>
+                    <c:v>Help button</c:v>
                   </c:pt>
                   <c:pt idx="3">
-                    <c:v>Help button</c:v>
+                    <c:v>Wait time at entrances</c:v>
                   </c:pt>
                   <c:pt idx="4">
                     <c:v>Live announcements</c:v>
@@ -299,25 +299,25 @@
                 <c:formatCode>General</c:formatCode>
                 <c:ptCount val="7"/>
                 <c:pt idx="0">
-                  <c:v>65</c:v>
+                  <c:v>67</c:v>
                 </c:pt>
                 <c:pt idx="1">
-                  <c:v>50</c:v>
+                  <c:v>54</c:v>
                 </c:pt>
                 <c:pt idx="2">
-                  <c:v>45</c:v>
+                  <c:v>46</c:v>
                 </c:pt>
                 <c:pt idx="3">
-                  <c:v>45</c:v>
+                  <c:v>42</c:v>
                 </c:pt>
                 <c:pt idx="4">
-                  <c:v>40</c:v>
+                  <c:v>38</c:v>
                 </c:pt>
                 <c:pt idx="5">
                   <c:v>25</c:v>
                 </c:pt>
                 <c:pt idx="6">
-                  <c:v>10</c:v>
+                  <c:v>8</c:v>
                 </c:pt>
               </c:numCache>
             </c:numRef>
@@ -941,7 +941,7 @@
           <a:p>
             <a:r>
               <a:rPr lang="en-US" dirty="0"/>
-              <a:t>(~50 s) Os pressupostos críticos são três. A2: os estudantes usam a aplicação durante a noite. O inquérito apoia, 85 % diz que sim, mas é intenção, não comportamento. A3: uma aplicação para vários eventos, aberta por link ou QR. Em parte: 35 % diz que instalar mais uma app os afastaria, o que confirma a decisão de não exigir instalação. A4: pedir ajuda pela app é mais rápido. Ainda não está validado, depende da entrevista ao voluntário de segurança. À direita, as dependências, cada uma com o seu plano B: a API do Porto Digital tem o WireMock; a IA local tem a triagem manual; as plantas vêm das organizações em imagem ou PDF; o acesso à organização é limitado e está documentado; e a demo corre num portátil, com outro de reserva.</a:t>
+              <a:t>(~50 s) Os pressupostos críticos são três. A2: os estudantes usam a aplicação durante a noite. O inquérito apoia, 88 % diz que sim, mas é intenção, não comportamento. A3: uma aplicação para vários eventos, aberta por link ou QR. Em parte: 29 % diz que instalar mais uma app os afastaria, o que confirma a decisão de não exigir instalação. A4: pedir ajuda pela app é mais rápido. Ainda não está validado, depende da entrevista ao voluntário de segurança. À direita, as dependências, cada uma com o seu plano B: a API do Porto Digital tem o WireMock; a IA local tem a triagem manual; as plantas vêm das organizações em imagem ou PDF; o acesso à organização é limitado e está documentado; e a demo corre num portátil, com outro de reserva.</a:t>
             </a:r>
             <a:endParaRPr lang="en-US" dirty="0"/>
           </a:p>
@@ -1821,7 +1821,7 @@
           <a:p>
             <a:r>
               <a:rPr lang="en-US" dirty="0"/>
-              <a:t>(~75 s) Fizemos um inquérito no Google Forms entre 3 e 6 de outubro. Tivemos 21 respostas; 20 de pessoas que já foram a uma Queima, todas à do Porto. É pouco, o objetivo eram 100, e é uma amostra de conveniência, por isso os números mostram direção, não valores exatos. Três coisas: primeiro, 85 % esperou mais de meia hora para entrar, é de longe o problema mais comum. Segundo, 85 % diz que usaria a aplicação durante a noite, acima da meta de 60 %. Terceiro, uma surpresa: a facilidade de encontrar informação teve média 3,7 em 5, por isso a falta de informação não é a dor principal destas pessoas. No gráfico, a planta do recinto é a funcionalidade mais escolhida, 65 %; o assistente de perguntas é a última, 10 %. As barreiras mais citadas foram rede fraca e bateria, 40 % cada.</a:t>
+              <a:t>(~75 s) Fizemos um inquérito no Google Forms em duas vagas: 21 respostas entre 3 e 6 de outubro e mais 4, a 30 de outubro, de amigos de um membro da equipa. Ficam 24 pessoas que já foram a uma Queima, quase todas à do Porto. É pouco, o objetivo eram 100, e é uma amostra de conveniência, por isso os números mostram direção, não valores exatos. Três coisas: primeiro, 88 % esperou mais de meia hora para entrar, é de longe o problema mais comum. Segundo, 88 % diz que usaria a aplicação durante a noite, acima da meta de 60 %. Terceiro, a facilidade de encontrar informação teve média 3,3 em 5, acima do limite de 3 que tínhamos definido, por isso não confirma o problema. Mas as duas vagas discordam muito, 3,7 na primeira e 1,25 na segunda, e as pessoas responderam em casa, longe do ruído e da confusão da noite, por isso fica em aberto até um teste em condições reais. No gráfico, a planta do recinto é a funcionalidade mais escolhida, 67 %; o assistente de perguntas é a última, 8 %. As barreiras mais citadas foram a bateria, 50 %, e a rede fraca, 38 %.</a:t>
             </a:r>
             <a:endParaRPr lang="en-US" dirty="0"/>
           </a:p>
@@ -1909,7 +1909,7 @@
           <a:p>
             <a:r>
               <a:rPr lang="en-US" dirty="0"/>
-              <a:t>(~60 s) Do inquérito tirámos cinco decisões. Duas confirmam o que já tínhamos: a planta é o centro da aplicação, e a IA fica na triagem dos pedidos de ajuda e não num chatbot para participantes, que quase ninguém escolheu. Três mudam o backlog e estão propostas à equipa: o estado das entradas por porta sobe de Could para Should, porque a espera é o problema mais comum; a rede fraca e a bateria passam a ser restrições de desenho, com páginas leves, e o modo de rede fraca volta a ser discutido; e no pedido de ajuda a marcação na planta continua a funcionar sempre, mas a localização do telemóvel passa a ser um atalho opcional, porque 80 % aceita partilhá-la e ninguém recusa. O pressuposto de que pedir ajuda pela app é mais rápido ainda não está validado: falta a entrevista ao voluntário de segurança.</a:t>
+              <a:t>(~60 s) Do inquérito tirámos cinco decisões. Duas confirmam o que já tínhamos: a planta é o centro da aplicação, e a IA fica na triagem dos pedidos de ajuda e não num chatbot para participantes, que quase ninguém escolheu. Três mudam o backlog e estão propostas à equipa: o estado das entradas por porta sobe de Could para Should, porque a espera é o problema mais comum; a rede fraca e a bateria passam a ser restrições de desenho, com páginas leves, e o modo de rede fraca volta a ser discutido; e no pedido de ajuda a marcação na planta continua a funcionar sempre, mas a localização do telemóvel passa a ser um atalho opcional, porque 79 % aceita partilhá-la e ninguém recusa. O pressuposto de que pedir ajuda pela app é mais rápido ainda não está validado: falta a entrevista ao voluntário de segurança.</a:t>
             </a:r>
             <a:endParaRPr lang="en-US" dirty="0"/>
           </a:p>
@@ -3574,7 +3574,7 @@
                   <a:schemeClr val="accent3"/>
                 </a:solidFill>
               </a:rPr>
-              <a:t>Supported: 85 % say they would (intention)</a:t>
+              <a:t>Supported: 88 % say they would (intention)</a:t>
             </a:r>
             <a:endParaRPr lang="en-US" sz="1200" dirty="0"/>
           </a:p>
@@ -3724,7 +3724,7 @@
                   <a:schemeClr val="accent3"/>
                 </a:solidFill>
               </a:rPr>
-              <a:t>Partly: 35 % name installing as a barrier</a:t>
+              <a:t>Partly: 29 % name installing as a barrier</a:t>
             </a:r>
             <a:endParaRPr lang="en-US" sz="1200" dirty="0"/>
           </a:p>
@@ -11680,7 +11680,7 @@
                   <a:schemeClr val="tx2"/>
                 </a:solidFill>
               </a:rPr>
-              <a:t>What 20 students told us</a:t>
+              <a:t>What 24 students told us</a:t>
             </a:r>
             <a:endParaRPr lang="en-US" sz="3000" dirty="0"/>
           </a:p>
@@ -11738,7 +11738,7 @@
                   <a:schemeClr val="accent5"/>
                 </a:solidFill>
               </a:rPr>
-              <a:t>85 %</a:t>
+              <a:t>88 %</a:t>
             </a:r>
             <a:endParaRPr lang="en-US" sz="3200" dirty="0"/>
           </a:p>
@@ -11832,7 +11832,7 @@
                   <a:schemeClr val="accent4"/>
                 </a:solidFill>
               </a:rPr>
-              <a:t>85 %</a:t>
+              <a:t>88 %</a:t>
             </a:r>
             <a:endParaRPr lang="en-US" sz="3200" dirty="0"/>
           </a:p>
@@ -11926,7 +11926,7 @@
                   <a:schemeClr val="accent2"/>
                 </a:solidFill>
               </a:rPr>
-              <a:t>3.7 / 5</a:t>
+              <a:t>3.3 / 5</a:t>
             </a:r>
             <a:endParaRPr lang="en-US" sz="3200" dirty="0"/>
           </a:p>
@@ -11962,7 +11962,7 @@
                   <a:schemeClr val="tx1"/>
                 </a:solidFill>
               </a:rPr>
-              <a:t>finding information was fairly easy (1–5)</a:t>
+              <a:t>ease of finding info · waves: 3.7 and 1.25</a:t>
             </a:r>
             <a:endParaRPr lang="en-US" sz="1300" dirty="0"/>
           </a:p>
@@ -12014,7 +12014,7 @@
                   <a:schemeClr val="accent3"/>
                 </a:solidFill>
               </a:rPr>
-              <a:t>Google Forms, 3–6 Oct 2026 · 21 answers, n = 20 who have been to a Queima · convenience sample, all from Porto</a:t>
+              <a:t>Google Forms, 3–6 Oct (21) and 30 Oct 2026 (4, friends of the team) · n = 24 who have been to a Queima · convenience sample</a:t>
             </a:r>
             <a:endParaRPr lang="en-US" sz="1100" dirty="0"/>
           </a:p>
@@ -12260,7 +12260,7 @@
                   <a:schemeClr val="accent3"/>
                 </a:solidFill>
               </a:rPr>
-              <a:t>Most chosen feature: 13 of 20</a:t>
+              <a:t>Most chosen feature: 16 of 24</a:t>
             </a:r>
             <a:endParaRPr lang="en-US" sz="1200" dirty="0"/>
           </a:p>
@@ -12456,7 +12456,7 @@
                   <a:schemeClr val="accent3"/>
                 </a:solidFill>
               </a:rPr>
-              <a:t>17 of 20 waited &gt; 30 min to get in</a:t>
+              <a:t>21 of 24 waited &gt; 30 min to get in</a:t>
             </a:r>
             <a:endParaRPr lang="en-US" sz="1200" dirty="0"/>
           </a:p>
@@ -12652,7 +12652,7 @@
                   <a:schemeClr val="accent3"/>
                 </a:solidFill>
               </a:rPr>
-              <a:t>Network and battery: 8 of 20 each</a:t>
+              <a:t>Battery 12 of 24, network 9 of 24</a:t>
             </a:r>
             <a:endParaRPr lang="en-US" sz="1200" dirty="0"/>
           </a:p>
@@ -12848,7 +12848,7 @@
                   <a:schemeClr val="accent3"/>
                 </a:solidFill>
               </a:rPr>
-              <a:t>16 of 20 share GPS; nobody refuses</a:t>
+              <a:t>19 of 24 share GPS; nobody refuses</a:t>
             </a:r>
             <a:endParaRPr lang="en-US" sz="1200" dirty="0"/>
           </a:p>
@@ -13044,7 +13044,7 @@
                   <a:schemeClr val="accent3"/>
                 </a:solidFill>
               </a:rPr>
-              <a:t>Assistant chosen by 2 of 20</a:t>
+              <a:t>Assistant chosen by 2 of 24</a:t>
             </a:r>
             <a:endParaRPr lang="en-US" sz="1200" dirty="0"/>
           </a:p>

</xml_diff>

<commit_message>
docs (#164): Add the third survey wave
Include the 8 answers of 30 October 2026 (22:49-22:57) as wave 3:
n = 31 for Q2-Q6 and 32 for Q7-Q10. The Q6 average is 2.97 overall,
3.70 in wave 1 and 1.64 in waves 2 and 3, so V2 is met only by the
overall average and is read as weak support. The deck describes the
waves without naming the recruitment; the report keeps it.

Co-Authored-By: Claude Opus 5.5 <noreply@anthropic.com>
</commit_message>
<xml_diff>
--- a/Docs/Presentation/Farol_Sprint_A_Presentation.pptx
+++ b/Docs/Presentation/Farol_Sprint_A_Presentation.pptx
@@ -124,12 +124,12 @@
   <p:extLst>
     <p:ext uri="{521415D9-36F7-43E2-AB2F-B90AF26B5E84}">
       <p14:sectionLst xmlns:p14="http://schemas.microsoft.com/office/powerpoint/2010/main">
-        <p14:section name="Opening" id="{dd3e3070-a4ec-3fee-245e-0181f093dc6b}">
+        <p14:section name="Opening" id="{66c22273-205e-0d3d-75c1-1c7b0afe3447}">
           <p14:sldIdLst>
             <p14:sldId id="256"/>
           </p14:sldIdLst>
         </p14:section>
-        <p14:section name="Product" id="{98e0ec4e-7d94-8ea3-3324-86e01e7e4837}">
+        <p14:section name="Product" id="{cce10b7c-c028-91ff-5ea3-a3b1ff6529b9}">
           <p14:sldIdLst>
             <p14:sldId id="257"/>
             <p14:sldId id="258"/>
@@ -138,7 +138,7 @@
             <p14:sldId id="261"/>
           </p14:sldIdLst>
         </p14:section>
-        <p14:section name="Design" id="{9f0186b3-7f19-0d3c-49d8-f6a014fc6eaf}">
+        <p14:section name="Design" id="{e733231d-48c7-7ec1-a67b-106ee591d0d3}">
           <p14:sldIdLst>
             <p14:sldId id="262"/>
             <p14:sldId id="263"/>
@@ -146,7 +146,7 @@
             <p14:sldId id="265"/>
           </p14:sldIdLst>
         </p14:section>
-        <p14:section name="Plan" id="{985a0404-c17e-c65f-0cf9-6bb18568a3f5}">
+        <p14:section name="Plan" id="{df8ffa44-1dde-fcd8-dc4c-5a5252ffc37f}">
           <p14:sldIdLst>
             <p14:sldId id="266"/>
             <p14:sldId id="267"/>
@@ -154,14 +154,14 @@
             <p14:sldId id="269"/>
           </p14:sldIdLst>
         </p14:section>
-        <p14:section name="Team" id="{23420e0b-593c-0179-c669-648405219c49}">
+        <p14:section name="Team" id="{0a1bca8e-3ba1-2e38-d9ce-3736203af46a}">
           <p14:sldIdLst>
             <p14:sldId id="270"/>
             <p14:sldId id="271"/>
             <p14:sldId id="272"/>
           </p14:sldIdLst>
         </p14:section>
-        <p14:section name="Closing" id="{73a94d4d-1964-fec1-bc2a-86158ef645d3}">
+        <p14:section name="Closing" id="{50832363-413b-e52d-63b5-0b4192625bb8}">
           <p14:sldIdLst>
             <p14:sldId id="273"/>
           </p14:sldIdLst>
@@ -201,7 +201,7 @@
                 </a:solidFill>
                 <a:latin typeface="+mn-lt"/>
               </a:rPr>
-              <a:t>Most useful features (% of 24, up to 3 each)</a:t>
+              <a:t>Most useful features (% of 32, up to 3 each)</a:t>
             </a:r>
           </a:p>
         </c:rich>
@@ -271,10 +271,10 @@
                     <c:v>Venue map</c:v>
                   </c:pt>
                   <c:pt idx="1">
-                    <c:v>Transport home</c:v>
+                    <c:v>Help button</c:v>
                   </c:pt>
                   <c:pt idx="2">
-                    <c:v>Help button</c:v>
+                    <c:v>Transport home</c:v>
                   </c:pt>
                   <c:pt idx="3">
                     <c:v>Wait time at entrances</c:v>
@@ -299,25 +299,25 @@
                 <c:formatCode>General</c:formatCode>
                 <c:ptCount val="7"/>
                 <c:pt idx="0">
-                  <c:v>67</c:v>
+                  <c:v>53</c:v>
                 </c:pt>
                 <c:pt idx="1">
-                  <c:v>54</c:v>
+                  <c:v>50</c:v>
                 </c:pt>
                 <c:pt idx="2">
-                  <c:v>46</c:v>
+                  <c:v>44</c:v>
                 </c:pt>
                 <c:pt idx="3">
-                  <c:v>42</c:v>
+                  <c:v>41</c:v>
                 </c:pt>
                 <c:pt idx="4">
                   <c:v>38</c:v>
                 </c:pt>
                 <c:pt idx="5">
-                  <c:v>25</c:v>
+                  <c:v>31</c:v>
                 </c:pt>
                 <c:pt idx="6">
-                  <c:v>8</c:v>
+                  <c:v>9</c:v>
                 </c:pt>
               </c:numCache>
             </c:numRef>
@@ -941,7 +941,7 @@
           <a:p>
             <a:r>
               <a:rPr lang="en-US" dirty="0"/>
-              <a:t>(~50 s) Os pressupostos críticos são três. A2: os estudantes usam a aplicação durante a noite. O inquérito apoia, 88 % diz que sim, mas é intenção, não comportamento. A3: uma aplicação para vários eventos, aberta por link ou QR. Em parte: 29 % diz que instalar mais uma app os afastaria, o que confirma a decisão de não exigir instalação. A4: pedir ajuda pela app é mais rápido. Ainda não está validado, depende da entrevista ao voluntário de segurança. À direita, as dependências, cada uma com o seu plano B: a API do Porto Digital tem o WireMock; a IA local tem a triagem manual; as plantas vêm das organizações em imagem ou PDF; o acesso à organização é limitado e está documentado; e a demo corre num portátil, com outro de reserva.</a:t>
+              <a:t>(~50 s) Os pressupostos críticos são três. A2: os estudantes usam a aplicação durante a noite. O inquérito apoia, 84 % diz que sim, mas é intenção, não comportamento. A3: uma aplicação para vários eventos, aberta por link ou QR. Em parte: 38 % diz que instalar mais uma app os afastaria, o que confirma a decisão de não exigir instalação. A4: pedir ajuda pela app é mais rápido. Ainda não está validado, depende da entrevista ao voluntário de segurança. À direita, as dependências, cada uma com o seu plano B: a API do Porto Digital tem o WireMock; a IA local tem a triagem manual; as plantas vêm das organizações em imagem ou PDF; o acesso à organização é limitado e está documentado; e a demo corre num portátil, com outro de reserva.</a:t>
             </a:r>
             <a:endParaRPr lang="en-US" dirty="0"/>
           </a:p>
@@ -1821,7 +1821,7 @@
           <a:p>
             <a:r>
               <a:rPr lang="en-US" dirty="0"/>
-              <a:t>(~75 s) Fizemos um inquérito no Google Forms em duas vagas: 21 respostas entre 3 e 6 de outubro e mais 4, a 30 de outubro, de amigos de um membro da equipa. Ficam 24 pessoas que já foram a uma Queima, quase todas à do Porto. É pouco, o objetivo eram 100, e é uma amostra de conveniência, por isso os números mostram direção, não valores exatos. Três coisas: primeiro, 88 % esperou mais de meia hora para entrar, é de longe o problema mais comum. Segundo, 88 % diz que usaria a aplicação durante a noite, acima da meta de 60 %. Terceiro, a facilidade de encontrar informação teve média 3,3 em 5, acima do limite de 3 que tínhamos definido, por isso não confirma o problema. Mas as duas vagas discordam muito, 3,7 na primeira e 1,25 na segunda, e as pessoas responderam em casa, longe do ruído e da confusão da noite, por isso fica em aberto até um teste em condições reais. No gráfico, a planta do recinto é a funcionalidade mais escolhida, 67 %; o assistente de perguntas é a última, 8 %. As barreiras mais citadas foram a bateria, 50 %, e a rede fraca, 38 %.</a:t>
+              <a:t>(~75 s) Fizemos um inquérito no Google Forms em três vagas: 21 respostas entre 3 e 6 de outubro e mais 12 a 30 de outubro. Ficam 31 pessoas que já foram a um festival académico, a maioria à Queima do Porto. É pouco, o objetivo eram 100, e é uma amostra de conveniência, por isso os números mostram direção, não valores exatos. Três coisas: primeiro, 77 % esperou mais de meia hora para entrar, é de longe o problema mais comum. Segundo, 84 % diz que usaria a aplicação durante a noite, acima da meta de 60 %. Terceiro, a facilidade de encontrar informação teve média 2,97 em 5, no limite da meta de 3. Mas as vagas discordam muito: a primeira sozinha dá 3,7 e as duas seguintes 1,6. Por isso tratamos este resultado como um indício fraco e vamos confirmá-lo com um teste em condições de noite, com ruído e rede lenta. No gráfico, a planta do recinto é a funcionalidade mais escolhida, 53 %, logo seguida do botão de ajuda, 50 %; o assistente de perguntas é a última, 9 %. A barreira mais citada foi a bateria, 47 %.</a:t>
             </a:r>
             <a:endParaRPr lang="en-US" dirty="0"/>
           </a:p>
@@ -1909,7 +1909,7 @@
           <a:p>
             <a:r>
               <a:rPr lang="en-US" dirty="0"/>
-              <a:t>(~60 s) Do inquérito tirámos cinco decisões. Duas confirmam o que já tínhamos: a planta é o centro da aplicação, e a IA fica na triagem dos pedidos de ajuda e não num chatbot para participantes, que quase ninguém escolheu. Três mudam o backlog e estão propostas à equipa: o estado das entradas por porta sobe de Could para Should, porque a espera é o problema mais comum; a rede fraca e a bateria passam a ser restrições de desenho, com páginas leves, e o modo de rede fraca volta a ser discutido; e no pedido de ajuda a marcação na planta continua a funcionar sempre, mas a localização do telemóvel passa a ser um atalho opcional, porque 79 % aceita partilhá-la e ninguém recusa. O pressuposto de que pedir ajuda pela app é mais rápido ainda não está validado: falta a entrevista ao voluntário de segurança.</a:t>
+              <a:t>(~60 s) Do inquérito tirámos cinco decisões. Duas confirmam o que já tínhamos: a planta é o centro da aplicação, e a IA fica na triagem dos pedidos de ajuda e não num chatbot para participantes, que quase ninguém escolheu. Três mudam o backlog e estão propostas à equipa: o estado das entradas por porta sobe de Could para Should, porque a espera é o problema mais comum; a rede fraca e a bateria passam a ser restrições de desenho, com páginas leves, e o modo de rede fraca volta a ser discutido; e no pedido de ajuda a marcação na planta continua a funcionar sempre, mas a localização do telemóvel passa a ser um atalho opcional, porque 69 % aceita partilhá-la e quase todos os outros preferem marcar o sítio na planta. O pressuposto de que pedir ajuda pela app é mais rápido ainda não está validado: falta a entrevista ao voluntário de segurança.</a:t>
             </a:r>
             <a:endParaRPr lang="en-US" dirty="0"/>
           </a:p>
@@ -3574,7 +3574,7 @@
                   <a:schemeClr val="accent3"/>
                 </a:solidFill>
               </a:rPr>
-              <a:t>Supported: 88 % say they would (intention)</a:t>
+              <a:t>Supported: 84 % say they would (intention)</a:t>
             </a:r>
             <a:endParaRPr lang="en-US" sz="1200" dirty="0"/>
           </a:p>
@@ -3724,7 +3724,7 @@
                   <a:schemeClr val="accent3"/>
                 </a:solidFill>
               </a:rPr>
-              <a:t>Partly: 29 % name installing as a barrier</a:t>
+              <a:t>Partly: 38 % name installing as a barrier</a:t>
             </a:r>
             <a:endParaRPr lang="en-US" sz="1200" dirty="0"/>
           </a:p>
@@ -11680,7 +11680,7 @@
                   <a:schemeClr val="tx2"/>
                 </a:solidFill>
               </a:rPr>
-              <a:t>What 24 students told us</a:t>
+              <a:t>What students told us</a:t>
             </a:r>
             <a:endParaRPr lang="en-US" sz="3000" dirty="0"/>
           </a:p>
@@ -11738,7 +11738,7 @@
                   <a:schemeClr val="accent5"/>
                 </a:solidFill>
               </a:rPr>
-              <a:t>88 %</a:t>
+              <a:t>77 %</a:t>
             </a:r>
             <a:endParaRPr lang="en-US" sz="3200" dirty="0"/>
           </a:p>
@@ -11832,7 +11832,7 @@
                   <a:schemeClr val="accent4"/>
                 </a:solidFill>
               </a:rPr>
-              <a:t>88 %</a:t>
+              <a:t>84 %</a:t>
             </a:r>
             <a:endParaRPr lang="en-US" sz="3200" dirty="0"/>
           </a:p>
@@ -11926,7 +11926,7 @@
                   <a:schemeClr val="accent2"/>
                 </a:solidFill>
               </a:rPr>
-              <a:t>3.3 / 5</a:t>
+              <a:t>2.97 / 5</a:t>
             </a:r>
             <a:endParaRPr lang="en-US" sz="3200" dirty="0"/>
           </a:p>
@@ -11962,7 +11962,7 @@
                   <a:schemeClr val="tx1"/>
                 </a:solidFill>
               </a:rPr>
-              <a:t>ease of finding info · waves: 3.7 and 1.25</a:t>
+              <a:t>ease of finding info · wave 1 alone: 3.7</a:t>
             </a:r>
             <a:endParaRPr lang="en-US" sz="1300" dirty="0"/>
           </a:p>
@@ -12014,7 +12014,7 @@
                   <a:schemeClr val="accent3"/>
                 </a:solidFill>
               </a:rPr>
-              <a:t>Google Forms, 3–6 Oct (21) and 30 Oct 2026 (4, friends of the team) · n = 24 who have been to a Queima · convenience sample</a:t>
+              <a:t>Google Forms in three waves (3–6 Oct and 30 Oct 2026) · 33 answers, n = 31 who have been · convenience sample</a:t>
             </a:r>
             <a:endParaRPr lang="en-US" sz="1100" dirty="0"/>
           </a:p>
@@ -12260,7 +12260,7 @@
                   <a:schemeClr val="accent3"/>
                 </a:solidFill>
               </a:rPr>
-              <a:t>Most chosen feature: 16 of 24</a:t>
+              <a:t>Most chosen feature: 17 of 32</a:t>
             </a:r>
             <a:endParaRPr lang="en-US" sz="1200" dirty="0"/>
           </a:p>
@@ -12456,7 +12456,7 @@
                   <a:schemeClr val="accent3"/>
                 </a:solidFill>
               </a:rPr>
-              <a:t>21 of 24 waited &gt; 30 min to get in</a:t>
+              <a:t>24 of 31 waited &gt; 30 min to get in</a:t>
             </a:r>
             <a:endParaRPr lang="en-US" sz="1200" dirty="0"/>
           </a:p>
@@ -12652,7 +12652,7 @@
                   <a:schemeClr val="accent3"/>
                 </a:solidFill>
               </a:rPr>
-              <a:t>Battery 12 of 24, network 9 of 24</a:t>
+              <a:t>Battery 15 of 32, network 10 of 32</a:t>
             </a:r>
             <a:endParaRPr lang="en-US" sz="1200" dirty="0"/>
           </a:p>
@@ -12848,7 +12848,7 @@
                   <a:schemeClr val="accent3"/>
                 </a:solidFill>
               </a:rPr>
-              <a:t>19 of 24 share GPS; nobody refuses</a:t>
+              <a:t>22 of 32 share GPS, 9 only the pin</a:t>
             </a:r>
             <a:endParaRPr lang="en-US" sz="1200" dirty="0"/>
           </a:p>
@@ -13044,7 +13044,7 @@
                   <a:schemeClr val="accent3"/>
                 </a:solidFill>
               </a:rPr>
-              <a:t>Assistant chosen by 2 of 24</a:t>
+              <a:t>Assistant chosen by 3 of 32</a:t>
             </a:r>
             <a:endParaRPr lang="en-US" sz="1200" dirty="0"/>
           </a:p>

</xml_diff>

<commit_message>
docs (#164): Show survey results as totals
Present every survey result as one total (n = 31 for Q2-Q6, 32 for
Q7-Q10) instead of per collection wave, in the report, the product
vision and the deck. One limitation keeps when the 30 October answers
were collected and the Q6 average without them.

Co-Authored-By: Claude Opus 5.5 <noreply@anthropic.com>
</commit_message>
<xml_diff>
--- a/Docs/Presentation/Farol_Sprint_A_Presentation.pptx
+++ b/Docs/Presentation/Farol_Sprint_A_Presentation.pptx
@@ -124,12 +124,12 @@
   <p:extLst>
     <p:ext uri="{521415D9-36F7-43E2-AB2F-B90AF26B5E84}">
       <p14:sectionLst xmlns:p14="http://schemas.microsoft.com/office/powerpoint/2010/main">
-        <p14:section name="Opening" id="{66c22273-205e-0d3d-75c1-1c7b0afe3447}">
+        <p14:section name="Opening" id="{374a2afd-8dac-82c4-49be-36b08240dee8}">
           <p14:sldIdLst>
             <p14:sldId id="256"/>
           </p14:sldIdLst>
         </p14:section>
-        <p14:section name="Product" id="{cce10b7c-c028-91ff-5ea3-a3b1ff6529b9}">
+        <p14:section name="Product" id="{f84b6e31-f104-2083-b934-89fd312814e0}">
           <p14:sldIdLst>
             <p14:sldId id="257"/>
             <p14:sldId id="258"/>
@@ -138,7 +138,7 @@
             <p14:sldId id="261"/>
           </p14:sldIdLst>
         </p14:section>
-        <p14:section name="Design" id="{e733231d-48c7-7ec1-a67b-106ee591d0d3}">
+        <p14:section name="Design" id="{bfae25ff-07b3-6269-57f5-6d0bb00d7986}">
           <p14:sldIdLst>
             <p14:sldId id="262"/>
             <p14:sldId id="263"/>
@@ -146,7 +146,7 @@
             <p14:sldId id="265"/>
           </p14:sldIdLst>
         </p14:section>
-        <p14:section name="Plan" id="{df8ffa44-1dde-fcd8-dc4c-5a5252ffc37f}">
+        <p14:section name="Plan" id="{42e7ee0a-6699-6015-7942-c854147819b2}">
           <p14:sldIdLst>
             <p14:sldId id="266"/>
             <p14:sldId id="267"/>
@@ -154,14 +154,14 @@
             <p14:sldId id="269"/>
           </p14:sldIdLst>
         </p14:section>
-        <p14:section name="Team" id="{0a1bca8e-3ba1-2e38-d9ce-3736203af46a}">
+        <p14:section name="Team" id="{75fdbe43-cc82-c9ea-b12e-70d5ad5e0037}">
           <p14:sldIdLst>
             <p14:sldId id="270"/>
             <p14:sldId id="271"/>
             <p14:sldId id="272"/>
           </p14:sldIdLst>
         </p14:section>
-        <p14:section name="Closing" id="{50832363-413b-e52d-63b5-0b4192625bb8}">
+        <p14:section name="Closing" id="{6c1e46ac-b5bc-ed91-647f-66e90f5c8d9c}">
           <p14:sldIdLst>
             <p14:sldId id="273"/>
           </p14:sldIdLst>
@@ -1821,7 +1821,7 @@
           <a:p>
             <a:r>
               <a:rPr lang="en-US" dirty="0"/>
-              <a:t>(~75 s) Fizemos um inquérito no Google Forms em três vagas: 21 respostas entre 3 e 6 de outubro e mais 12 a 30 de outubro. Ficam 31 pessoas que já foram a um festival académico, a maioria à Queima do Porto. É pouco, o objetivo eram 100, e é uma amostra de conveniência, por isso os números mostram direção, não valores exatos. Três coisas: primeiro, 77 % esperou mais de meia hora para entrar, é de longe o problema mais comum. Segundo, 84 % diz que usaria a aplicação durante a noite, acima da meta de 60 %. Terceiro, a facilidade de encontrar informação teve média 2,97 em 5, no limite da meta de 3. Mas as vagas discordam muito: a primeira sozinha dá 3,7 e as duas seguintes 1,6. Por isso tratamos este resultado como um indício fraco e vamos confirmá-lo com um teste em condições de noite, com ruído e rede lenta. No gráfico, a planta do recinto é a funcionalidade mais escolhida, 53 %, logo seguida do botão de ajuda, 50 %; o assistente de perguntas é a última, 9 %. A barreira mais citada foi a bateria, 47 %.</a:t>
+              <a:t>(~75 s) Fizemos um inquérito no Google Forms entre 3 e 6 de outubro e a 30 de outubro, com 33 respostas. Ficam 31 pessoas que já foram a um festival académico, a maioria à Queima do Porto. É pouco, o objetivo eram 100, e é uma amostra de conveniência, por isso os números mostram direção, não valores exatos. Três coisas: primeiro, 77 % esperou mais de meia hora para entrar, é de longe o problema mais comum. Segundo, 84 % diz que usaria a aplicação durante a noite, acima da meta de 60 %. Terceiro, a facilidade de encontrar informação teve média 2,97 em 5, mesmo no limite da meta de 3, e o resultado depende das respostas de 30 de outubro; por isso vamos confirmá-lo com um teste em condições de noite, com ruído e rede lenta. No gráfico, a planta do recinto é a funcionalidade mais escolhida, 53 %, logo seguida do botão de ajuda, 50 %; o assistente de perguntas é a última, 9 %. A barreira mais citada foi a bateria, 47 %.</a:t>
             </a:r>
             <a:endParaRPr lang="en-US" dirty="0"/>
           </a:p>
@@ -11962,7 +11962,7 @@
                   <a:schemeClr val="tx1"/>
                 </a:solidFill>
               </a:rPr>
-              <a:t>ease of finding info · wave 1 alone: 3.7</a:t>
+              <a:t>ease of finding information (1–5)</a:t>
             </a:r>
             <a:endParaRPr lang="en-US" sz="1300" dirty="0"/>
           </a:p>
@@ -12014,7 +12014,7 @@
                   <a:schemeClr val="accent3"/>
                 </a:solidFill>
               </a:rPr>
-              <a:t>Google Forms in three waves (3–6 Oct and 30 Oct 2026) · 33 answers, n = 31 who have been · convenience sample</a:t>
+              <a:t>Google Forms, 3–6 and 30 Oct 2026 · 33 answers, n = 31 who have been to a festival · convenience sample</a:t>
             </a:r>
             <a:endParaRPr lang="en-US" sz="1100" dirty="0"/>
           </a:p>

</xml_diff>

<commit_message>
docs (#164): Apply Tiago's survey decisions
Mark the joke answer invalid and exclude it entirely (32 valid
answers; n = 30 for Q2-Q6, 31 for Q7-Q10). Decisions on F17, F11 and
F6 are decided by Tiago as backlog owner; F6 now asks for the phone's
location first, with the venue map as the fallback. Deck and product
vision follow the new numbers.

Co-Authored-By: Claude Opus 5.5 <noreply@anthropic.com>
</commit_message>
<xml_diff>
--- a/Docs/Presentation/Farol_Sprint_A_Presentation.pptx
+++ b/Docs/Presentation/Farol_Sprint_A_Presentation.pptx
@@ -124,12 +124,12 @@
   <p:extLst>
     <p:ext uri="{521415D9-36F7-43E2-AB2F-B90AF26B5E84}">
       <p14:sectionLst xmlns:p14="http://schemas.microsoft.com/office/powerpoint/2010/main">
-        <p14:section name="Opening" id="{374a2afd-8dac-82c4-49be-36b08240dee8}">
+        <p14:section name="Opening" id="{e7b5d382-112e-55e4-9f3f-ec4adb3b9acc}">
           <p14:sldIdLst>
             <p14:sldId id="256"/>
           </p14:sldIdLst>
         </p14:section>
-        <p14:section name="Product" id="{f84b6e31-f104-2083-b934-89fd312814e0}">
+        <p14:section name="Product" id="{184b4c8b-7c6c-6c76-b760-5958322696a2}">
           <p14:sldIdLst>
             <p14:sldId id="257"/>
             <p14:sldId id="258"/>
@@ -138,7 +138,7 @@
             <p14:sldId id="261"/>
           </p14:sldIdLst>
         </p14:section>
-        <p14:section name="Design" id="{bfae25ff-07b3-6269-57f5-6d0bb00d7986}">
+        <p14:section name="Design" id="{288eb3a8-013b-d5ec-57a2-8a646247092a}">
           <p14:sldIdLst>
             <p14:sldId id="262"/>
             <p14:sldId id="263"/>
@@ -146,7 +146,7 @@
             <p14:sldId id="265"/>
           </p14:sldIdLst>
         </p14:section>
-        <p14:section name="Plan" id="{42e7ee0a-6699-6015-7942-c854147819b2}">
+        <p14:section name="Plan" id="{52a9c346-c652-72e7-517a-59a719764e94}">
           <p14:sldIdLst>
             <p14:sldId id="266"/>
             <p14:sldId id="267"/>
@@ -154,14 +154,14 @@
             <p14:sldId id="269"/>
           </p14:sldIdLst>
         </p14:section>
-        <p14:section name="Team" id="{75fdbe43-cc82-c9ea-b12e-70d5ad5e0037}">
+        <p14:section name="Team" id="{abeefc53-192b-898c-490d-bc4199dd3b23}">
           <p14:sldIdLst>
             <p14:sldId id="270"/>
             <p14:sldId id="271"/>
             <p14:sldId id="272"/>
           </p14:sldIdLst>
         </p14:section>
-        <p14:section name="Closing" id="{6c1e46ac-b5bc-ed91-647f-66e90f5c8d9c}">
+        <p14:section name="Closing" id="{7e9be91b-49f2-49c9-cd0b-d78e89aa4f39}">
           <p14:sldIdLst>
             <p14:sldId id="273"/>
           </p14:sldIdLst>
@@ -201,7 +201,7 @@
                 </a:solidFill>
                 <a:latin typeface="+mn-lt"/>
               </a:rPr>
-              <a:t>Most useful features (% of 32, up to 3 each)</a:t>
+              <a:t>Most useful features (% of 31, up to 3 each)</a:t>
             </a:r>
           </a:p>
         </c:rich>
@@ -299,25 +299,25 @@
                 <c:formatCode>General</c:formatCode>
                 <c:ptCount val="7"/>
                 <c:pt idx="0">
-                  <c:v>53</c:v>
+                  <c:v>52</c:v>
                 </c:pt>
                 <c:pt idx="1">
-                  <c:v>50</c:v>
+                  <c:v>48</c:v>
                 </c:pt>
                 <c:pt idx="2">
-                  <c:v>44</c:v>
+                  <c:v>45</c:v>
                 </c:pt>
                 <c:pt idx="3">
-                  <c:v>41</c:v>
+                  <c:v>39</c:v>
                 </c:pt>
                 <c:pt idx="4">
-                  <c:v>38</c:v>
+                  <c:v>39</c:v>
                 </c:pt>
                 <c:pt idx="5">
-                  <c:v>31</c:v>
+                  <c:v>32</c:v>
                 </c:pt>
                 <c:pt idx="6">
-                  <c:v>9</c:v>
+                  <c:v>10</c:v>
                 </c:pt>
               </c:numCache>
             </c:numRef>
@@ -941,7 +941,7 @@
           <a:p>
             <a:r>
               <a:rPr lang="en-US" dirty="0"/>
-              <a:t>(~50 s) Os pressupostos críticos são três. A2: os estudantes usam a aplicação durante a noite. O inquérito apoia, 84 % diz que sim, mas é intenção, não comportamento. A3: uma aplicação para vários eventos, aberta por link ou QR. Em parte: 38 % diz que instalar mais uma app os afastaria, o que confirma a decisão de não exigir instalação. A4: pedir ajuda pela app é mais rápido. Ainda não está validado, depende da entrevista ao voluntário de segurança. À direita, as dependências, cada uma com o seu plano B: a API do Porto Digital tem o WireMock; a IA local tem a triagem manual; as plantas vêm das organizações em imagem ou PDF; o acesso à organização é limitado e está documentado; e a demo corre num portátil, com outro de reserva.</a:t>
+              <a:t>(~50 s) Os pressupostos críticos são três. A2: os estudantes usam a aplicação durante a noite. O inquérito apoia, 87 % diz que sim, mas é intenção, não comportamento. A3: uma aplicação para vários eventos, aberta por link ou QR. Em parte: 39 % diz que instalar mais uma app os afastaria, o que confirma a decisão de não exigir instalação. A4: pedir ajuda pela app é mais rápido. Ainda não está validado, depende da entrevista ao voluntário de segurança. À direita, as dependências, cada uma com o seu plano B: a API do Porto Digital tem o WireMock; a IA local tem a triagem manual; as plantas vêm das organizações em imagem ou PDF; o acesso à organização é limitado e está documentado; e a demo corre num portátil, com outro de reserva.</a:t>
             </a:r>
             <a:endParaRPr lang="en-US" dirty="0"/>
           </a:p>
@@ -1645,7 +1645,7 @@
           <a:p>
             <a:r>
               <a:rPr lang="en-US" dirty="0"/>
-              <a:t>(~30 s) Próximos passos: pôr o walking skeleton a correr antes de 2 de novembro; fazer a entrevista ao voluntário de segurança para validar o pressuposto A4 e as personas do Miguel e da Inês; confirmar em equipa as mudanças ao backlog que o inquérito sugere; e entregar a fatia vertical a 6 de dezembro. Obrigado, ficamos para perguntas.</a:t>
+              <a:t>(~30 s) Próximos passos: pôr o walking skeleton a correr antes de 2 de novembro; fazer a entrevista ao voluntário de segurança para validar o pressuposto A4 e as personas do Miguel e da Inês; aplicar ao backlog as mudanças que o inquérito trouxe, no próximo planeamento; e entregar a fatia vertical a 6 de dezembro. Obrigado, ficamos para perguntas.</a:t>
             </a:r>
             <a:endParaRPr lang="en-US" dirty="0"/>
           </a:p>
@@ -1821,7 +1821,7 @@
           <a:p>
             <a:r>
               <a:rPr lang="en-US" dirty="0"/>
-              <a:t>(~75 s) Fizemos um inquérito no Google Forms entre 3 e 6 de outubro e a 30 de outubro, com 33 respostas. Ficam 31 pessoas que já foram a um festival académico, a maioria à Queima do Porto. É pouco, o objetivo eram 100, e é uma amostra de conveniência, por isso os números mostram direção, não valores exatos. Três coisas: primeiro, 77 % esperou mais de meia hora para entrar, é de longe o problema mais comum. Segundo, 84 % diz que usaria a aplicação durante a noite, acima da meta de 60 %. Terceiro, a facilidade de encontrar informação teve média 2,97 em 5, mesmo no limite da meta de 3, e o resultado depende das respostas de 30 de outubro; por isso vamos confirmá-lo com um teste em condições de noite, com ruído e rede lenta. No gráfico, a planta do recinto é a funcionalidade mais escolhida, 53 %, logo seguida do botão de ajuda, 50 %; o assistente de perguntas é a última, 9 %. A barreira mais citada foi a bateria, 47 %.</a:t>
+              <a:t>(~75 s) Fizemos um inquérito no Google Forms entre 3 e 6 de outubro e a 30 de outubro, com 32 respostas válidas. Ficam 30 pessoas que já foram a um festival académico, a maioria à Queima do Porto. É pouco, o objetivo eram 100, e é uma amostra de conveniência, por isso os números mostram direção, não valores exatos. Três coisas: primeiro, 80 % esperou mais de meia hora para entrar, é de longe o problema mais comum. Segundo, 87 % diz que usaria a aplicação durante a noite, acima da meta de 60 %. Terceiro, a facilidade de encontrar informação teve média 2,97 em 5, mesmo no limite da meta de 3, e o resultado depende das respostas de 30 de outubro; por isso vamos confirmá-lo com um teste em condições de noite, com ruído e rede lenta. No gráfico, a planta do recinto é a funcionalidade mais escolhida, 52 %, logo seguida do botão de ajuda, 48 %; o assistente de perguntas é a última, 10 %. A barreira mais citada foi a bateria, 48 %.</a:t>
             </a:r>
             <a:endParaRPr lang="en-US" dirty="0"/>
           </a:p>
@@ -1909,7 +1909,7 @@
           <a:p>
             <a:r>
               <a:rPr lang="en-US" dirty="0"/>
-              <a:t>(~60 s) Do inquérito tirámos cinco decisões. Duas confirmam o que já tínhamos: a planta é o centro da aplicação, e a IA fica na triagem dos pedidos de ajuda e não num chatbot para participantes, que quase ninguém escolheu. Três mudam o backlog e estão propostas à equipa: o estado das entradas por porta sobe de Could para Should, porque a espera é o problema mais comum; a rede fraca e a bateria passam a ser restrições de desenho, com páginas leves, e o modo de rede fraca volta a ser discutido; e no pedido de ajuda a marcação na planta continua a funcionar sempre, mas a localização do telemóvel passa a ser um atalho opcional, porque 69 % aceita partilhá-la e quase todos os outros preferem marcar o sítio na planta. O pressuposto de que pedir ajuda pela app é mais rápido ainda não está validado: falta a entrevista ao voluntário de segurança.</a:t>
+              <a:t>(~60 s) Do inquérito tirámos cinco decisões. Duas confirmam o que já tínhamos: a planta é o centro da aplicação, e a IA fica na triagem dos pedidos de ajuda e não num chatbot para participantes, que quase ninguém escolheu. Três mudam o backlog: o estado das entradas por porta sobe de Could para Should, porque a espera é o problema mais comum; a bateria e a rede fraca passam a ser restrições de desenho, com páginas leves, e o modo de rede fraca volta a ser discutido; e no pedido de ajuda a aplicação pede a localização do telemóvel, que 71 % aceita partilhar, e quem recusar marca o sítio na planta. O pressuposto de que pedir ajuda pela app é mais rápido ainda não está validado: falta a entrevista ao voluntário de segurança.</a:t>
             </a:r>
             <a:endParaRPr lang="en-US" dirty="0"/>
           </a:p>
@@ -2085,7 +2085,7 @@
           <a:p>
             <a:r>
               <a:rPr lang="en-US" dirty="0"/>
-              <a:t>(~60 s) O percurso central é o pedido de ajuda. A Rita toca em Pedir ajuda; primeiro aparece o 112 e, se não for emergência, escolhe a categoria e marca o sítio na planta. O pedido fica guardado logo e aparece na sala de controlo em menos de 5 segundos. Em paralelo, a IA sugere categoria, prioridade e equipa em menos de 30 segundos; se a IA falhar, o pedido aparece como Não triado, e nada se perde. O Miguel confirma ou altera e encaminha para uma equipa. A Inês aceita no telemóvel, vai ao sítio marcado e fecha o pedido. A Rita acompanha o estado ao vivo. Em baixo estão os outros percursos: encontrar informação, criar e configurar um evento, publicar um aviso, reportar um problema e ganhar um badge, e o check-in.</a:t>
+              <a:t>(~60 s) O percurso central é o pedido de ajuda. A Rita toca em Pedir ajuda; primeiro aparece o 112 e, se não for emergência, escolhe a categoria e partilha a localização do telemóvel; se recusar, marca o sítio na planta. O pedido fica guardado logo e aparece na sala de controlo em menos de 5 segundos. Em paralelo, a IA sugere categoria, prioridade e equipa em menos de 30 segundos; se a IA falhar, o pedido aparece como Não triado, e nada se perde. O Miguel confirma ou altera e encaminha para uma equipa. A Inês aceita no telemóvel, vai ao sítio indicado e fecha o pedido. A Rita acompanha o estado ao vivo. Em baixo estão os outros percursos: encontrar informação, criar e configurar um evento, publicar um aviso, reportar um problema e ganhar um badge, e o check-in.</a:t>
             </a:r>
             <a:endParaRPr lang="en-US" dirty="0"/>
           </a:p>
@@ -3574,7 +3574,7 @@
                   <a:schemeClr val="accent3"/>
                 </a:solidFill>
               </a:rPr>
-              <a:t>Supported: 84 % say they would (intention)</a:t>
+              <a:t>Supported: 87 % say they would (intention)</a:t>
             </a:r>
             <a:endParaRPr lang="en-US" sz="1200" dirty="0"/>
           </a:p>
@@ -3724,7 +3724,7 @@
                   <a:schemeClr val="accent3"/>
                 </a:solidFill>
               </a:rPr>
-              <a:t>Partly: 38 % name installing as a barrier</a:t>
+              <a:t>Partly: 39 % name installing as a barrier</a:t>
             </a:r>
             <a:endParaRPr lang="en-US" sz="1200" dirty="0"/>
           </a:p>
@@ -5998,7 +5998,7 @@
                   <a:schemeClr val="accent3"/>
                 </a:solidFill>
               </a:rPr>
-              <a:t>* survey proposes moving up (team to confirm) · MoSCoW, then P0–P2 and XS–XL on the GitHub Projects board · features.md</a:t>
+              <a:t>* reviewed after the survey: F17 moves to Should, F11 back to planning · MoSCoW, then P0–P2 and XS–XL on the board</a:t>
             </a:r>
             <a:endParaRPr lang="en-US" sz="1100" dirty="0"/>
           </a:p>
@@ -10851,7 +10851,7 @@
                   <a:schemeClr val="bg1"/>
                 </a:solidFill>
               </a:rPr>
-              <a:t>Team confirms the survey changes to the backlog</a:t>
+              <a:t>Apply the survey changes to the backlog</a:t>
             </a:r>
             <a:endParaRPr lang="en-US" sz="1600" dirty="0"/>
           </a:p>
@@ -11260,7 +11260,7 @@
                   <a:schemeClr val="tx1"/>
                 </a:solidFill>
               </a:rPr>
-              <a:t>Find the map, entrances and transport home; ask for help with the place marked on the map.</a:t>
+              <a:t>Find the map, entrances and transport home; ask for help with their location, or a spot marked on the map.</a:t>
             </a:r>
             <a:endParaRPr lang="en-US" sz="1400" dirty="0"/>
           </a:p>
@@ -11738,7 +11738,7 @@
                   <a:schemeClr val="accent5"/>
                 </a:solidFill>
               </a:rPr>
-              <a:t>77 %</a:t>
+              <a:t>80 %</a:t>
             </a:r>
             <a:endParaRPr lang="en-US" sz="3200" dirty="0"/>
           </a:p>
@@ -11832,7 +11832,7 @@
                   <a:schemeClr val="accent4"/>
                 </a:solidFill>
               </a:rPr>
-              <a:t>84 %</a:t>
+              <a:t>87 %</a:t>
             </a:r>
             <a:endParaRPr lang="en-US" sz="3200" dirty="0"/>
           </a:p>
@@ -12014,7 +12014,7 @@
                   <a:schemeClr val="accent3"/>
                 </a:solidFill>
               </a:rPr>
-              <a:t>Google Forms, 3–6 and 30 Oct 2026 · 33 answers, n = 31 who have been to a festival · convenience sample</a:t>
+              <a:t>Google Forms, 3–6 and 30 Oct 2026 · 32 valid answers, n = 30 who have been to a festival · convenience sample</a:t>
             </a:r>
             <a:endParaRPr lang="en-US" sz="1100" dirty="0"/>
           </a:p>
@@ -12260,7 +12260,7 @@
                   <a:schemeClr val="accent3"/>
                 </a:solidFill>
               </a:rPr>
-              <a:t>Most chosen feature: 17 of 32</a:t>
+              <a:t>Most chosen feature: 16 of 31</a:t>
             </a:r>
             <a:endParaRPr lang="en-US" sz="1200" dirty="0"/>
           </a:p>
@@ -12456,7 +12456,7 @@
                   <a:schemeClr val="accent3"/>
                 </a:solidFill>
               </a:rPr>
-              <a:t>24 of 31 waited &gt; 30 min to get in</a:t>
+              <a:t>24 of 30 waited &gt; 30 min to get in</a:t>
             </a:r>
             <a:endParaRPr lang="en-US" sz="1200" dirty="0"/>
           </a:p>
@@ -12514,7 +12514,7 @@
                   <a:schemeClr val="tx2"/>
                 </a:solidFill>
               </a:rPr>
-              <a:t>Proposed</a:t>
+              <a:t>Decided</a:t>
             </a:r>
             <a:endParaRPr lang="en-US" sz="1100" dirty="0"/>
           </a:p>
@@ -12652,7 +12652,7 @@
                   <a:schemeClr val="accent3"/>
                 </a:solidFill>
               </a:rPr>
-              <a:t>Battery 15 of 32, network 10 of 32</a:t>
+              <a:t>Battery 15 of 31, network 10 of 31</a:t>
             </a:r>
             <a:endParaRPr lang="en-US" sz="1200" dirty="0"/>
           </a:p>
@@ -12710,7 +12710,7 @@
                   <a:schemeClr val="tx2"/>
                 </a:solidFill>
               </a:rPr>
-              <a:t>Proposed</a:t>
+              <a:t>Decided</a:t>
             </a:r>
             <a:endParaRPr lang="en-US" sz="1100" dirty="0"/>
           </a:p>
@@ -12812,7 +12812,7 @@
                   <a:schemeClr val="tx2"/>
                 </a:solidFill>
               </a:rPr>
-              <a:t>Help: map pin always, phone location optional</a:t>
+              <a:t>Help: phone location first, map as fallback</a:t>
             </a:r>
             <a:endParaRPr lang="en-US" sz="1500" dirty="0"/>
           </a:p>
@@ -12848,7 +12848,7 @@
                   <a:schemeClr val="accent3"/>
                 </a:solidFill>
               </a:rPr>
-              <a:t>22 of 32 share GPS, 9 only the pin</a:t>
+              <a:t>22 of 31 share GPS, 8 only the map</a:t>
             </a:r>
             <a:endParaRPr lang="en-US" sz="1200" dirty="0"/>
           </a:p>
@@ -12906,7 +12906,7 @@
                   <a:schemeClr val="tx2"/>
                 </a:solidFill>
               </a:rPr>
-              <a:t>Proposed</a:t>
+              <a:t>Decided</a:t>
             </a:r>
             <a:endParaRPr lang="en-US" sz="1100" dirty="0"/>
           </a:p>
@@ -13044,7 +13044,7 @@
                   <a:schemeClr val="accent3"/>
                 </a:solidFill>
               </a:rPr>
-              <a:t>Assistant chosen by 3 of 32</a:t>
+              <a:t>Assistant chosen by 3 of 31</a:t>
             </a:r>
             <a:endParaRPr lang="en-US" sz="1200" dirty="0"/>
           </a:p>
@@ -13138,7 +13138,7 @@
                   <a:schemeClr val="accent3"/>
                 </a:solidFill>
               </a:rPr>
-              <a:t>Proposed changes go to the backlog after the team confirms them · A4 (help is faster) waits for the security-volunteer interview</a:t>
+              <a:t>Backlog changes applied at the next planning · A4 (help is faster) waits for the security-volunteer interview</a:t>
             </a:r>
             <a:endParaRPr lang="en-US" sz="1100" dirty="0"/>
           </a:p>
@@ -14614,7 +14614,7 @@
                   <a:schemeClr val="tx1"/>
                 </a:solidFill>
               </a:rPr>
-              <a:t>Asks for help: category and the spot on the map (112 shown first)</a:t>
+              <a:t>Asks for help: category and her phone location, or a spot on the map (112 first)</a:t>
             </a:r>
             <a:endParaRPr lang="en-US" sz="1200" dirty="0"/>
           </a:p>

</xml_diff>

<commit_message>
docs (#164): Apply survey decisions to features
F17 moves to Should (US-59 and US-60 into R2 if there is time, first
in the cut line); F11 is reopened as a candidate for Should; F6 and
US-23 ask for the phone's location first, with the map as fallback.
The report, changelog and deck follow.

Co-Authored-By: Claude Opus 5.5 <noreply@anthropic.com>
</commit_message>
<xml_diff>
--- a/Docs/Presentation/Farol_Sprint_A_Presentation.pptx
+++ b/Docs/Presentation/Farol_Sprint_A_Presentation.pptx
@@ -124,12 +124,12 @@
   <p:extLst>
     <p:ext uri="{521415D9-36F7-43E2-AB2F-B90AF26B5E84}">
       <p14:sectionLst xmlns:p14="http://schemas.microsoft.com/office/powerpoint/2010/main">
-        <p14:section name="Opening" id="{e7b5d382-112e-55e4-9f3f-ec4adb3b9acc}">
+        <p14:section name="Opening" id="{4180bb3a-e06e-3cb4-8259-dd9152db3c56}">
           <p14:sldIdLst>
             <p14:sldId id="256"/>
           </p14:sldIdLst>
         </p14:section>
-        <p14:section name="Product" id="{184b4c8b-7c6c-6c76-b760-5958322696a2}">
+        <p14:section name="Product" id="{2bb0c058-a98c-663f-b1db-1b1f314679d1}">
           <p14:sldIdLst>
             <p14:sldId id="257"/>
             <p14:sldId id="258"/>
@@ -138,7 +138,7 @@
             <p14:sldId id="261"/>
           </p14:sldIdLst>
         </p14:section>
-        <p14:section name="Design" id="{288eb3a8-013b-d5ec-57a2-8a646247092a}">
+        <p14:section name="Design" id="{44c0aea5-c14f-0563-c601-84f6af1bf2de}">
           <p14:sldIdLst>
             <p14:sldId id="262"/>
             <p14:sldId id="263"/>
@@ -146,7 +146,7 @@
             <p14:sldId id="265"/>
           </p14:sldIdLst>
         </p14:section>
-        <p14:section name="Plan" id="{52a9c346-c652-72e7-517a-59a719764e94}">
+        <p14:section name="Plan" id="{8233a9d8-be00-77fc-2851-2714e7106e00}">
           <p14:sldIdLst>
             <p14:sldId id="266"/>
             <p14:sldId id="267"/>
@@ -154,14 +154,14 @@
             <p14:sldId id="269"/>
           </p14:sldIdLst>
         </p14:section>
-        <p14:section name="Team" id="{abeefc53-192b-898c-490d-bc4199dd3b23}">
+        <p14:section name="Team" id="{18886c6f-e2e8-fe7e-5118-b3c0e591fff1}">
           <p14:sldIdLst>
             <p14:sldId id="270"/>
             <p14:sldId id="271"/>
             <p14:sldId id="272"/>
           </p14:sldIdLst>
         </p14:section>
-        <p14:section name="Closing" id="{7e9be91b-49f2-49c9-cd0b-d78e89aa4f39}">
+        <p14:section name="Closing" id="{eba572aa-79f9-216e-bd35-e4ad85e9cc00}">
           <p14:sldIdLst>
             <p14:sldId id="273"/>
           </p14:sldIdLst>
@@ -1117,7 +1117,7 @@
           <a:p>
             <a:r>
               <a:rPr lang="en-US" dirty="0"/>
-              <a:t>(~50 s) O backlog tem 20 funcionalidades, priorizadas com MoSCoW, e 62 user stories no board do GitHub Projects, com prioridade P0 a P2 e tamanho. As Must cobrem o percurso principal: login, eventos, papéis e equipas, a planta, o pedido de ajuda, o backoffice de incidentes, a triagem com IA, os transportes do Porto Digital, os avisos, e os reports com confirmação e badges, que são o nosso mecanismo de envolvimento ético. Should: badges de presença e check-in. Could: modo de rede fraca, estado das entradas e amigos; as duas primeiras, com asterisco, o inquérito propõe subir. Won't nesta versão: chat e ligação ao bilhete.</a:t>
+              <a:t>(~50 s) O backlog tem 20 funcionalidades, priorizadas com MoSCoW, e 62 user stories no board do GitHub Projects, com prioridade P0 a P2 e tamanho. As Must cobrem o percurso principal: login, eventos, papéis e equipas, a planta, o pedido de ajuda, o backoffice de incidentes, a triagem com IA, os transportes do Porto Digital, os avisos, e os reports com confirmação e badges, que são o nosso mecanismo de envolvimento ético. Should: badges de presença, check-in e, depois do inquérito, o estado das entradas, porque a espera é o problema mais comum. Could: modo de rede fraca e amigos; o modo de rede fraca, com asterisco, volta a ser discutido no planeamento como candidato a Should. Won't nesta versão: chat e ligação ao bilhete.</a:t>
             </a:r>
             <a:endParaRPr lang="en-US" dirty="0"/>
           </a:p>
@@ -1645,7 +1645,7 @@
           <a:p>
             <a:r>
               <a:rPr lang="en-US" dirty="0"/>
-              <a:t>(~30 s) Próximos passos: pôr o walking skeleton a correr antes de 2 de novembro; fazer a entrevista ao voluntário de segurança para validar o pressuposto A4 e as personas do Miguel e da Inês; aplicar ao backlog as mudanças que o inquérito trouxe, no próximo planeamento; e entregar a fatia vertical a 6 de dezembro. Obrigado, ficamos para perguntas.</a:t>
+              <a:t>(~30 s) Próximos passos: pôr o walking skeleton a correr antes de 2 de novembro; fazer a entrevista ao voluntário de segurança para validar o pressuposto A4 e as personas do Miguel e da Inês; decidir no próximo planeamento se o modo de rede fraca sobe para Should, como o inquérito sugere; e entregar a fatia vertical a 6 de dezembro. Obrigado, ficamos para perguntas.</a:t>
             </a:r>
             <a:endParaRPr lang="en-US" dirty="0"/>
           </a:p>
@@ -5677,6 +5677,23 @@
             </a:r>
             <a:endParaRPr lang="en-US" sz="1200" dirty="0"/>
           </a:p>
+          <a:p>
+            <a:pPr indent="0" marL="0">
+              <a:spcAft>
+                <a:spcPts val="600"/>
+              </a:spcAft>
+              <a:buNone/>
+            </a:pPr>
+            <a:r>
+              <a:rPr lang="en-US" sz="1200" dirty="0">
+                <a:solidFill>
+                  <a:schemeClr val="tx1"/>
+                </a:solidFill>
+              </a:rPr>
+              <a:t>F17 Entrance status *</a:t>
+            </a:r>
+            <a:endParaRPr lang="en-US" sz="1200" dirty="0"/>
+          </a:p>
         </p:txBody>
       </p:sp>
       <p:sp>
@@ -5809,10 +5826,112 @@
                   <a:schemeClr val="tx1"/>
                 </a:solidFill>
               </a:rPr>
-              <a:t>F17 Entrance status *</a:t>
+              <a:t>F18 Friends</a:t>
             </a:r>
             <a:endParaRPr lang="en-US" sz="1200" dirty="0"/>
           </a:p>
+        </p:txBody>
+      </p:sp>
+      <p:sp>
+        <p:nvSpPr>
+          <p:cNvPr id="16" name="Shape 14"/>
+          <p:cNvSpPr/>
+          <p:nvPr/>
+        </p:nvSpPr>
+        <p:spPr>
+          <a:xfrm>
+            <a:off x="7178040" y="1005840"/>
+            <a:ext cx="1508760" cy="411480"/>
+          </a:xfrm>
+          <a:prstGeom prst="roundRect">
+            <a:avLst>
+              <a:gd name="adj" fmla="val 17778"/>
+            </a:avLst>
+          </a:prstGeom>
+          <a:solidFill>
+            <a:schemeClr val="accent3"/>
+          </a:solidFill>
+          <a:ln/>
+        </p:spPr>
+      </p:sp>
+      <p:sp>
+        <p:nvSpPr>
+          <p:cNvPr id="17" name="Text 15"/>
+          <p:cNvSpPr txBox="1"/>
+          <p:nvPr/>
+        </p:nvSpPr>
+        <p:spPr>
+          <a:xfrm>
+            <a:off x="7178040" y="1005840"/>
+            <a:ext cx="1508760" cy="411480"/>
+          </a:xfrm>
+          <a:prstGeom prst="rect">
+            <a:avLst/>
+          </a:prstGeom>
+          <a:noFill/>
+          <a:ln/>
+        </p:spPr>
+        <p:txBody>
+          <a:bodyPr wrap="square" lIns="0" tIns="0" rIns="0" bIns="0" rtlCol="0" anchor="ctr"/>
+          <a:lstStyle/>
+          <a:p>
+            <a:pPr algn="ctr" indent="0" marL="0">
+              <a:buNone/>
+            </a:pPr>
+            <a:r>
+              <a:rPr lang="en-US" sz="1500" b="1" dirty="0">
+                <a:solidFill>
+                  <a:schemeClr val="bg1"/>
+                </a:solidFill>
+              </a:rPr>
+              <a:t>Won't (now)</a:t>
+            </a:r>
+            <a:endParaRPr lang="en-US" sz="1500" dirty="0"/>
+          </a:p>
+        </p:txBody>
+      </p:sp>
+      <p:sp>
+        <p:nvSpPr>
+          <p:cNvPr id="18" name="Shape 16"/>
+          <p:cNvSpPr/>
+          <p:nvPr/>
+        </p:nvSpPr>
+        <p:spPr>
+          <a:xfrm>
+            <a:off x="7178040" y="1508760"/>
+            <a:ext cx="1508760" cy="2971800"/>
+          </a:xfrm>
+          <a:prstGeom prst="roundRect">
+            <a:avLst>
+              <a:gd name="adj" fmla="val 7273"/>
+            </a:avLst>
+          </a:prstGeom>
+          <a:solidFill>
+            <a:schemeClr val="bg2"/>
+          </a:solidFill>
+          <a:ln/>
+        </p:spPr>
+      </p:sp>
+      <p:sp>
+        <p:nvSpPr>
+          <p:cNvPr id="19" name="Text 17"/>
+          <p:cNvSpPr txBox="1"/>
+          <p:nvPr/>
+        </p:nvSpPr>
+        <p:spPr>
+          <a:xfrm>
+            <a:off x="7287768" y="1627632"/>
+            <a:ext cx="1289304" cy="2743200"/>
+          </a:xfrm>
+          <a:prstGeom prst="rect">
+            <a:avLst/>
+          </a:prstGeom>
+          <a:noFill/>
+          <a:ln/>
+        </p:spPr>
+        <p:txBody>
+          <a:bodyPr wrap="square" lIns="0" tIns="0" rIns="0" bIns="0" rtlCol="0" anchor="t"/>
+          <a:lstStyle/>
           <a:p>
             <a:pPr indent="0" marL="0">
               <a:spcAft>
@@ -5826,112 +5945,10 @@
                   <a:schemeClr val="tx1"/>
                 </a:solidFill>
               </a:rPr>
-              <a:t>F18 Friends</a:t>
+              <a:t>F19 Chat</a:t>
             </a:r>
             <a:endParaRPr lang="en-US" sz="1200" dirty="0"/>
           </a:p>
-        </p:txBody>
-      </p:sp>
-      <p:sp>
-        <p:nvSpPr>
-          <p:cNvPr id="16" name="Shape 14"/>
-          <p:cNvSpPr/>
-          <p:nvPr/>
-        </p:nvSpPr>
-        <p:spPr>
-          <a:xfrm>
-            <a:off x="7178040" y="1005840"/>
-            <a:ext cx="1508760" cy="411480"/>
-          </a:xfrm>
-          <a:prstGeom prst="roundRect">
-            <a:avLst>
-              <a:gd name="adj" fmla="val 17778"/>
-            </a:avLst>
-          </a:prstGeom>
-          <a:solidFill>
-            <a:schemeClr val="accent3"/>
-          </a:solidFill>
-          <a:ln/>
-        </p:spPr>
-      </p:sp>
-      <p:sp>
-        <p:nvSpPr>
-          <p:cNvPr id="17" name="Text 15"/>
-          <p:cNvSpPr txBox="1"/>
-          <p:nvPr/>
-        </p:nvSpPr>
-        <p:spPr>
-          <a:xfrm>
-            <a:off x="7178040" y="1005840"/>
-            <a:ext cx="1508760" cy="411480"/>
-          </a:xfrm>
-          <a:prstGeom prst="rect">
-            <a:avLst/>
-          </a:prstGeom>
-          <a:noFill/>
-          <a:ln/>
-        </p:spPr>
-        <p:txBody>
-          <a:bodyPr wrap="square" lIns="0" tIns="0" rIns="0" bIns="0" rtlCol="0" anchor="ctr"/>
-          <a:lstStyle/>
-          <a:p>
-            <a:pPr algn="ctr" indent="0" marL="0">
-              <a:buNone/>
-            </a:pPr>
-            <a:r>
-              <a:rPr lang="en-US" sz="1500" b="1" dirty="0">
-                <a:solidFill>
-                  <a:schemeClr val="bg1"/>
-                </a:solidFill>
-              </a:rPr>
-              <a:t>Won't (now)</a:t>
-            </a:r>
-            <a:endParaRPr lang="en-US" sz="1500" dirty="0"/>
-          </a:p>
-        </p:txBody>
-      </p:sp>
-      <p:sp>
-        <p:nvSpPr>
-          <p:cNvPr id="18" name="Shape 16"/>
-          <p:cNvSpPr/>
-          <p:nvPr/>
-        </p:nvSpPr>
-        <p:spPr>
-          <a:xfrm>
-            <a:off x="7178040" y="1508760"/>
-            <a:ext cx="1508760" cy="2971800"/>
-          </a:xfrm>
-          <a:prstGeom prst="roundRect">
-            <a:avLst>
-              <a:gd name="adj" fmla="val 7273"/>
-            </a:avLst>
-          </a:prstGeom>
-          <a:solidFill>
-            <a:schemeClr val="bg2"/>
-          </a:solidFill>
-          <a:ln/>
-        </p:spPr>
-      </p:sp>
-      <p:sp>
-        <p:nvSpPr>
-          <p:cNvPr id="19" name="Text 17"/>
-          <p:cNvSpPr txBox="1"/>
-          <p:nvPr/>
-        </p:nvSpPr>
-        <p:spPr>
-          <a:xfrm>
-            <a:off x="7287768" y="1627632"/>
-            <a:ext cx="1289304" cy="2743200"/>
-          </a:xfrm>
-          <a:prstGeom prst="rect">
-            <a:avLst/>
-          </a:prstGeom>
-          <a:noFill/>
-          <a:ln/>
-        </p:spPr>
-        <p:txBody>
-          <a:bodyPr wrap="square" lIns="0" tIns="0" rIns="0" bIns="0" rtlCol="0" anchor="t"/>
-          <a:lstStyle/>
           <a:p>
             <a:pPr indent="0" marL="0">
               <a:spcAft>
@@ -5945,23 +5962,6 @@
                   <a:schemeClr val="tx1"/>
                 </a:solidFill>
               </a:rPr>
-              <a:t>F19 Chat</a:t>
-            </a:r>
-            <a:endParaRPr lang="en-US" sz="1200" dirty="0"/>
-          </a:p>
-          <a:p>
-            <a:pPr indent="0" marL="0">
-              <a:spcAft>
-                <a:spcPts val="600"/>
-              </a:spcAft>
-              <a:buNone/>
-            </a:pPr>
-            <a:r>
-              <a:rPr lang="en-US" sz="1200" dirty="0">
-                <a:solidFill>
-                  <a:schemeClr val="tx1"/>
-                </a:solidFill>
-              </a:rPr>
               <a:t>F20 Ticket link</a:t>
             </a:r>
             <a:endParaRPr lang="en-US" sz="1200" dirty="0"/>
@@ -5998,7 +5998,7 @@
                   <a:schemeClr val="accent3"/>
                 </a:solidFill>
               </a:rPr>
-              <a:t>* reviewed after the survey: F17 moves to Should, F11 back to planning · MoSCoW, then P0–P2 and XS–XL on the board</a:t>
+              <a:t>* changed after the survey: F17 up to Should; F11 a candidate for Should · MoSCoW, then P0–P2 and XS–XL on the board</a:t>
             </a:r>
             <a:endParaRPr lang="en-US" sz="1100" dirty="0"/>
           </a:p>
@@ -10851,7 +10851,7 @@
                   <a:schemeClr val="bg1"/>
                 </a:solidFill>
               </a:rPr>
-              <a:t>Apply the survey changes to the backlog</a:t>
+              <a:t>Decide on weak-network mode (F11) after the survey</a:t>
             </a:r>
             <a:endParaRPr lang="en-US" sz="1600" dirty="0"/>
           </a:p>
@@ -13138,7 +13138,7 @@
                   <a:schemeClr val="accent3"/>
                 </a:solidFill>
               </a:rPr>
-              <a:t>Backlog changes applied at the next planning · A4 (help is faster) waits for the security-volunteer interview</a:t>
+              <a:t>Backlog changes applied in features.md on 30 Oct · A4 (help is faster) waits for the security-volunteer interview</a:t>
             </a:r>
             <a:endParaRPr lang="en-US" sz="1100" dirty="0"/>
           </a:p>

</xml_diff>

<commit_message>
docs (#164): Align the deck with the merged PRs
ADR-005 and ADR-012 are accepted, SonarQube is in the pipeline, Ollama
sits behind WireMock and the walking skeleton is done (31 October), so
slides 8, 9, 14 and 18 and their notes follow.

Co-Authored-By: Claude Opus 5.5 <noreply@anthropic.com>
</commit_message>
<xml_diff>
--- a/Docs/Presentation/Farol_Sprint_A_Presentation.pptx
+++ b/Docs/Presentation/Farol_Sprint_A_Presentation.pptx
@@ -124,12 +124,12 @@
   <p:extLst>
     <p:ext uri="{521415D9-36F7-43E2-AB2F-B90AF26B5E84}">
       <p14:sectionLst xmlns:p14="http://schemas.microsoft.com/office/powerpoint/2010/main">
-        <p14:section name="Opening" id="{4180bb3a-e06e-3cb4-8259-dd9152db3c56}">
+        <p14:section name="Opening" id="{f18a03a8-203b-e953-6ae5-78fab7fdbd35}">
           <p14:sldIdLst>
             <p14:sldId id="256"/>
           </p14:sldIdLst>
         </p14:section>
-        <p14:section name="Product" id="{2bb0c058-a98c-663f-b1db-1b1f314679d1}">
+        <p14:section name="Product" id="{1e8b1d06-d22e-02f5-7898-d6a2675f3c62}">
           <p14:sldIdLst>
             <p14:sldId id="257"/>
             <p14:sldId id="258"/>
@@ -138,7 +138,7 @@
             <p14:sldId id="261"/>
           </p14:sldIdLst>
         </p14:section>
-        <p14:section name="Design" id="{44c0aea5-c14f-0563-c601-84f6af1bf2de}">
+        <p14:section name="Design" id="{251047b5-e642-31be-a66e-6ebf8800e96c}">
           <p14:sldIdLst>
             <p14:sldId id="262"/>
             <p14:sldId id="263"/>
@@ -146,7 +146,7 @@
             <p14:sldId id="265"/>
           </p14:sldIdLst>
         </p14:section>
-        <p14:section name="Plan" id="{8233a9d8-be00-77fc-2851-2714e7106e00}">
+        <p14:section name="Plan" id="{439c860b-81d8-b573-8ec7-0afdb6a645b3}">
           <p14:sldIdLst>
             <p14:sldId id="266"/>
             <p14:sldId id="267"/>
@@ -154,14 +154,14 @@
             <p14:sldId id="269"/>
           </p14:sldIdLst>
         </p14:section>
-        <p14:section name="Team" id="{18886c6f-e2e8-fe7e-5118-b3c0e591fff1}">
+        <p14:section name="Team" id="{a1bb1ef4-437e-3bac-b9a7-75a259ffba5d}">
           <p14:sldIdLst>
             <p14:sldId id="270"/>
             <p14:sldId id="271"/>
             <p14:sldId id="272"/>
           </p14:sldIdLst>
         </p14:section>
-        <p14:section name="Closing" id="{eba572aa-79f9-216e-bd35-e4ad85e9cc00}">
+        <p14:section name="Closing" id="{e5664093-db36-aefc-0dc2-2f322c4fef6a}">
           <p14:sldIdLst>
             <p14:sldId id="273"/>
           </p14:sldIdLst>
@@ -1293,7 +1293,7 @@
           <a:p>
             <a:r>
               <a:rPr lang="en-US" dirty="0"/>
-              <a:t>(~50 s) O plano de entregas. Antes de 2 de novembro, o walking skeleton: um endpoint, um teste, um Dockerfile e o pipeline, a correr localmente. O Sprint B, de 2 de novembro a 6 de dezembro, entrega a fatia vertical: um participante pede ajuda na planta, a sala de controlo vê o pedido com a sugestão da IA, ou sem ela se a IA falhar, e encaminha para uma equipa que o aceita e resolve. São 27 stories. O Sprint C, até 3 de janeiro, completa o MVP: contas, transportes com shuttles e o aviso do modo degradado, avisos, reports e badges, e a avaliação da IA contra a alternativa sem IA. Se o tempo apertar, já temos definido o que cai primeiro.</a:t>
+              <a:t>(~50 s) O plano de entregas. O walking skeleton já está feito, a 31 de outubro: o serviço Reports cria e lê pedidos de ajuda sintéticos, com health check, testes HTTP, Dockerfile, Docker Compose e um smoke test no CI. O Sprint B, de 2 de novembro a 6 de dezembro, entrega a fatia vertical: um participante pede ajuda na planta, a sala de controlo vê o pedido com a sugestão da IA, ou sem ela se a IA falhar, e encaminha para uma equipa que o aceita e resolve. São 27 stories. O Sprint C, até 3 de janeiro, completa o MVP: contas, transportes com shuttles e o aviso do modo degradado, avisos, reports e badges, e a avaliação da IA contra a alternativa sem IA. Se o tempo apertar, já temos definido o que cai primeiro.</a:t>
             </a:r>
             <a:endParaRPr lang="en-US" dirty="0"/>
           </a:p>
@@ -1645,7 +1645,7 @@
           <a:p>
             <a:r>
               <a:rPr lang="en-US" dirty="0"/>
-              <a:t>(~30 s) Próximos passos: pôr o walking skeleton a correr antes de 2 de novembro; fazer a entrevista ao voluntário de segurança para validar o pressuposto A4 e as personas do Miguel e da Inês; decidir no próximo planeamento se o modo de rede fraca sobe para Should, como o inquérito sugere; e entregar a fatia vertical a 6 de dezembro. Obrigado, ficamos para perguntas.</a:t>
+              <a:t>(~30 s) Próximos passos: o Sprint B começa a 2 de novembro, a partir do walking skeleton que já está a correr; fazer a entrevista ao voluntário de segurança para validar o pressuposto A4 e as personas do Miguel e da Inês; decidir no próximo planeamento se o modo de rede fraca sobe para Should, como o inquérito sugere; e entregar a fatia vertical a 6 de dezembro. Obrigado, ficamos para perguntas.</a:t>
             </a:r>
             <a:endParaRPr lang="en-US" dirty="0"/>
           </a:p>
@@ -2261,7 +2261,7 @@
           <a:p>
             <a:r>
               <a:rPr lang="en-US" dirty="0"/>
-              <a:t>(~75 s) A arquitetura. Há uma única aplicação web em React, com páginas pensadas para o telemóvel ou para o portátil. Tudo entra pelo API gateway, que valida o token do Keycloak, aplica CORS e limites por conta. Atrás há cinco microserviços em Spring Boot, cada um com a sua base de dados PostgreSQL e o seu Dockerfile, desde o Sprint A. Os serviços não chamam a API uns dos outros: comunicam só por eventos no RabbitMQ, com tabela de outbox, consumidores idempotentes e filas de dead letter, por isso nenhum pedido se perde. A triagem é o fluxo assíncrono: o Reports publica o pedido e o worker chama o modelo local, Ollama com qwen3 de 4 mil milhões de parâmetros. A integração externa é a API de autocarros do Porto Digital, com o WireMock para testes e para a demo. Os dois modos degradados: sem IA, o pedido aparece como Não triado; sem transportes, mostramos os últimos dados válidos com aviso. Tudo corre localmente com Docker Compose, com autorização do professor por causa dos custos.</a:t>
+              <a:t>(~75 s) A arquitetura. Há uma única aplicação web em React, com páginas pensadas para o telemóvel ou para o portátil. Tudo entra pelo API gateway, que valida o token do Keycloak, aplica CORS e limites por conta. Atrás há cinco microserviços em Spring Boot, cada um com a sua base de dados PostgreSQL e o seu Dockerfile, desde o Sprint A. Os serviços não chamam a API uns dos outros: comunicam só por eventos no RabbitMQ, com tabela de outbox, consumidores idempotentes e filas de dead letter, por isso nenhum pedido se perde. A triagem é o fluxo assíncrono: o Reports publica o pedido e o worker chama o modelo local, Ollama com qwen3 de 4 mil milhões de parâmetros, através do WireMock, que também serve para simular falhas. A integração externa é a API de autocarros do Porto Digital, com o WireMock para testes e para a demo. Os dois modos degradados: sem IA, o pedido aparece como Não triado; sem transportes, mostramos os últimos dados válidos com aviso. Tudo corre localmente com Docker Compose, com autorização do professor por causa dos custos.</a:t>
             </a:r>
             <a:endParaRPr lang="en-US" dirty="0"/>
           </a:p>
@@ -2349,7 +2349,7 @@
           <a:p>
             <a:r>
               <a:rPr lang="en-US" dirty="0"/>
-              <a:t>(~45 s) A stack: Java 21 com Spring Boot 4 no backend, uma aplicação React no frontend, PostgreSQL com Flyway, RabbitMQ para mensagens, Keycloak para identidade e Spring Cloud Gateway à entrada. A entrega usa GitHub Actions e Docker Compose, e os testes de carga usam k6. Todas as decisões estão em 13 ADRs, cada um com a escolha, as alternativas e o porquê. Dois ainda estão Propostos: o fornecedor de IA e a observabilidade, que fecham com a revisão da equipa.</a:t>
+              <a:t>(~45 s) A stack: Java 21 com Spring Boot 4 no backend, uma aplicação React no frontend, PostgreSQL com Flyway, RabbitMQ para mensagens, Keycloak para identidade e Spring Cloud Gateway à entrada. A entrega usa GitHub Actions, com análise de qualidade no SonarQube Cloud, e Docker Compose, e os testes de carga usam k6. Todas as decisões estão em 13 ADRs, cada um com a escolha, as alternativas e o porquê. Estão todos aceites; nos da IA e da observabilidade falta ainda a evidência a correr, que chega com o Sprint B.</a:t>
             </a:r>
             <a:endParaRPr lang="en-US" dirty="0"/>
           </a:p>
@@ -7251,7 +7251,7 @@
                   <a:schemeClr val="accent2"/>
                 </a:solidFill>
               </a:rPr>
-              <a:t>before 2 Nov</a:t>
+              <a:t>done 31 Oct</a:t>
             </a:r>
             <a:endParaRPr lang="en-US" sz="1200" dirty="0"/>
           </a:p>
@@ -7287,7 +7287,7 @@
                   <a:schemeClr val="tx1"/>
                 </a:solidFill>
               </a:rPr>
-              <a:t>One endpoint, one test, a Dockerfile and the pipeline, running locally</a:t>
+              <a:t>Reports service: creates and reads synthetic help requests, with health check, HTTP tests, Dockerfile, Compose and CI smoke test</a:t>
             </a:r>
             <a:endParaRPr lang="en-US" sz="1200" dirty="0"/>
           </a:p>
@@ -10667,7 +10667,7 @@
                   <a:schemeClr val="bg1"/>
                 </a:solidFill>
               </a:rPr>
-              <a:t>Walking skeleton (R0) running locally</a:t>
+              <a:t>Sprint B starts from the walking skeleton</a:t>
             </a:r>
             <a:endParaRPr lang="en-US" sz="1600" dirty="0"/>
           </a:p>
@@ -10703,7 +10703,7 @@
                   <a:schemeClr val="accent1"/>
                 </a:solidFill>
               </a:rPr>
-              <a:t>before 2 Nov</a:t>
+              <a:t>2 Nov</a:t>
             </a:r>
             <a:endParaRPr lang="en-US" sz="1400" dirty="0"/>
           </a:p>
@@ -18829,7 +18829,7 @@
                   <a:schemeClr val="tx2"/>
                 </a:solidFill>
               </a:rPr>
-              <a:t>AI triage, called</a:t>
+              <a:t>via WireMock, called</a:t>
             </a:r>
             <a:endParaRPr lang="en-US" sz="1000" dirty="0"/>
           </a:p>
@@ -20047,7 +20047,21 @@
                   <a:schemeClr val="tx1"/>
                 </a:solidFill>
               </a:rPr>
-              <a:t>GitHub Actions · Docker Compose · k6</a:t>
+              <a:t>Actions · SonarQube</a:t>
+            </a:r>
+            <a:endParaRPr lang="en-US" sz="1200" dirty="0"/>
+          </a:p>
+          <a:p>
+            <a:pPr indent="0" marL="0">
+              <a:buNone/>
+            </a:pPr>
+            <a:r>
+              <a:rPr lang="en-US" sz="1200" dirty="0">
+                <a:solidFill>
+                  <a:schemeClr val="tx1"/>
+                </a:solidFill>
+              </a:rPr>
+              <a:t>Compose · k6</a:t>
             </a:r>
             <a:endParaRPr lang="en-US" sz="1200" dirty="0"/>
           </a:p>
@@ -20212,7 +20226,7 @@
                   <a:schemeClr val="bg1"/>
                 </a:solidFill>
               </a:rPr>
-              <a:t>005 AI triage provider (Proposed)</a:t>
+              <a:t>005 AI triage: local Ollama</a:t>
             </a:r>
             <a:endParaRPr lang="en-US" sz="1100" dirty="0"/>
           </a:p>
@@ -20331,7 +20345,7 @@
                   <a:schemeClr val="bg1"/>
                 </a:solidFill>
               </a:rPr>
-              <a:t>012 Observability (Proposed)</a:t>
+              <a:t>012 Observability: Prometheus, Grafana</a:t>
             </a:r>
             <a:endParaRPr lang="en-US" sz="1100" dirty="0"/>
           </a:p>

</xml_diff>

<commit_message>
docs (#164): Correct four deck claims
Remove 112 from the core journey (T5, 12 October 2026), say the
walking skeleton keeps requests in memory, say only Reports runs
today, and say the Copilot review is requested but has not run.

Co-Authored-By: Claude Opus 5.5 <noreply@anthropic.com>
</commit_message>
<xml_diff>
--- a/Docs/Presentation/Farol_Sprint_A_Presentation.pptx
+++ b/Docs/Presentation/Farol_Sprint_A_Presentation.pptx
@@ -124,12 +124,12 @@
   <p:extLst>
     <p:ext uri="{521415D9-36F7-43E2-AB2F-B90AF26B5E84}">
       <p14:sectionLst xmlns:p14="http://schemas.microsoft.com/office/powerpoint/2010/main">
-        <p14:section name="Opening" id="{f18a03a8-203b-e953-6ae5-78fab7fdbd35}">
+        <p14:section name="Opening" id="{8caf8f23-3048-a462-1b6b-8852486b0395}">
           <p14:sldIdLst>
             <p14:sldId id="256"/>
           </p14:sldIdLst>
         </p14:section>
-        <p14:section name="Product" id="{1e8b1d06-d22e-02f5-7898-d6a2675f3c62}">
+        <p14:section name="Product" id="{0ed65b43-ed74-7b4d-ba5a-185f421e25bf}">
           <p14:sldIdLst>
             <p14:sldId id="257"/>
             <p14:sldId id="258"/>
@@ -138,7 +138,7 @@
             <p14:sldId id="261"/>
           </p14:sldIdLst>
         </p14:section>
-        <p14:section name="Design" id="{251047b5-e642-31be-a66e-6ebf8800e96c}">
+        <p14:section name="Design" id="{27800aa2-b1a1-0314-9798-b1adda926b5e}">
           <p14:sldIdLst>
             <p14:sldId id="262"/>
             <p14:sldId id="263"/>
@@ -146,7 +146,7 @@
             <p14:sldId id="265"/>
           </p14:sldIdLst>
         </p14:section>
-        <p14:section name="Plan" id="{439c860b-81d8-b573-8ec7-0afdb6a645b3}">
+        <p14:section name="Plan" id="{a51a2b36-4e5f-146a-4e98-265bd08e512f}">
           <p14:sldIdLst>
             <p14:sldId id="266"/>
             <p14:sldId id="267"/>
@@ -154,14 +154,14 @@
             <p14:sldId id="269"/>
           </p14:sldIdLst>
         </p14:section>
-        <p14:section name="Team" id="{a1bb1ef4-437e-3bac-b9a7-75a259ffba5d}">
+        <p14:section name="Team" id="{bbf90b3d-cc83-282f-dbf8-9d0d27506586}">
           <p14:sldIdLst>
             <p14:sldId id="270"/>
             <p14:sldId id="271"/>
             <p14:sldId id="272"/>
           </p14:sldIdLst>
         </p14:section>
-        <p14:section name="Closing" id="{e5664093-db36-aefc-0dc2-2f322c4fef6a}">
+        <p14:section name="Closing" id="{63f182c1-69f6-ecb0-3588-b1b205717527}">
           <p14:sldIdLst>
             <p14:sldId id="273"/>
           </p14:sldIdLst>
@@ -1293,7 +1293,7 @@
           <a:p>
             <a:r>
               <a:rPr lang="en-US" dirty="0"/>
-              <a:t>(~50 s) O plano de entregas. O walking skeleton já está feito, a 31 de outubro: o serviço Reports cria e lê pedidos de ajuda sintéticos, com health check, testes HTTP, Dockerfile, Docker Compose e um smoke test no CI. O Sprint B, de 2 de novembro a 6 de dezembro, entrega a fatia vertical: um participante pede ajuda na planta, a sala de controlo vê o pedido com a sugestão da IA, ou sem ela se a IA falhar, e encaminha para uma equipa que o aceita e resolve. São 27 stories. O Sprint C, até 3 de janeiro, completa o MVP: contas, transportes com shuttles e o aviso do modo degradado, avisos, reports e badges, e a avaliação da IA contra a alternativa sem IA. Se o tempo apertar, já temos definido o que cai primeiro.</a:t>
+              <a:t>(~50 s) O plano de entregas. O walking skeleton já está feito, a 31 de outubro: o serviço Reports cria e lê pedidos de ajuda sintéticos, em memória, ainda sem base de dados, com health check, testes HTTP, Dockerfile, Docker Compose e um smoke test no CI. O Sprint B, de 2 de novembro a 6 de dezembro, entrega a fatia vertical: um participante pede ajuda na planta, a sala de controlo vê o pedido com a sugestão da IA, ou sem ela se a IA falhar, e encaminha para uma equipa que o aceita e resolve. São 27 stories. O Sprint C, até 3 de janeiro, completa o MVP: contas, transportes com shuttles e o aviso do modo degradado, avisos, reports e badges, e a avaliação da IA contra a alternativa sem IA. Se o tempo apertar, já temos definido o que cai primeiro.</a:t>
             </a:r>
             <a:endParaRPr lang="en-US" dirty="0"/>
           </a:p>
@@ -1469,7 +1469,7 @@
           <a:p>
             <a:r>
               <a:rPr lang="en-US" dirty="0"/>
-              <a:t>(~45 s) Trabalhamos com GitHub Flow. Todo o trabalho começa numa issue; a regra é uma user story, uma issue, um pull request. O branch é curto, o PR passa pela verificação automática das convenções, pelo pipeline de CI, pela revisão do Copilot e pela aprovação de outro membro, e entra com squash merge. O main está sempre pronto a entregar. Temos duas reuniões por semana: o planeamento na aula e o stand-up ao fim de semana, mais a review com os investidores no fim de cada sprint. O board do GitHub Projects segue o estado de cada item, de Backlog a Done.</a:t>
+              <a:t>(~45 s) Trabalhamos com GitHub Flow. Todo o trabalho começa numa issue; a regra é uma user story, uma issue, um pull request. O branch é curto, o PR passa pela verificação automática das convenções, pelo pipeline de CI e pela aprovação de outro membro, e entra com squash merge. A revisão do Copilot é pedida em todos os PRs, mas até agora falhou sempre por falta de quota. O main está sempre pronto a entregar. Temos duas reuniões por semana: o planeamento na aula e o stand-up ao fim de semana, mais a review com os investidores no fim de cada sprint. O board do GitHub Projects segue o estado de cada item, de Backlog a Done.</a:t>
             </a:r>
             <a:endParaRPr lang="en-US" dirty="0"/>
           </a:p>
@@ -2085,7 +2085,7 @@
           <a:p>
             <a:r>
               <a:rPr lang="en-US" dirty="0"/>
-              <a:t>(~60 s) O percurso central é o pedido de ajuda. A Rita toca em Pedir ajuda; primeiro aparece o 112 e, se não for emergência, escolhe a categoria e partilha a localização do telemóvel; se recusar, marca o sítio na planta. O pedido fica guardado logo e aparece na sala de controlo em menos de 5 segundos. Em paralelo, a IA sugere categoria, prioridade e equipa em menos de 30 segundos; se a IA falhar, o pedido aparece como Não triado, e nada se perde. O Miguel confirma ou altera e encaminha para uma equipa. A Inês aceita no telemóvel, vai ao sítio indicado e fecha o pedido. A Rita acompanha o estado ao vivo. Em baixo estão os outros percursos: encontrar informação, criar e configurar um evento, publicar um aviso, reportar um problema e ganhar um badge, e o check-in.</a:t>
+              <a:t>(~60 s) O percurso central é o pedido de ajuda. A Rita toca em Pedir ajuda, escolhe a categoria e partilha a localização do telemóvel; se recusar, marca o sítio na planta. O pedido fica guardado logo e aparece na sala de controlo em menos de 5 segundos. Em paralelo, a IA sugere categoria, prioridade e equipa em menos de 30 segundos; se a IA falhar, o pedido aparece como Não triado, e nada se perde. O Miguel confirma ou altera e encaminha para uma equipa. A Inês aceita no telemóvel, vai ao sítio indicado e fecha o pedido. A Rita acompanha o estado ao vivo. Em baixo estão os outros percursos: encontrar informação, criar e configurar um evento, publicar um aviso, reportar um problema e ganhar um badge, e o check-in.</a:t>
             </a:r>
             <a:endParaRPr lang="en-US" dirty="0"/>
           </a:p>
@@ -2261,7 +2261,7 @@
           <a:p>
             <a:r>
               <a:rPr lang="en-US" dirty="0"/>
-              <a:t>(~75 s) A arquitetura. Há uma única aplicação web em React, com páginas pensadas para o telemóvel ou para o portátil. Tudo entra pelo API gateway, que valida o token do Keycloak, aplica CORS e limites por conta. Atrás há cinco microserviços em Spring Boot, cada um com a sua base de dados PostgreSQL e o seu Dockerfile, desde o Sprint A. Os serviços não chamam a API uns dos outros: comunicam só por eventos no RabbitMQ, com tabela de outbox, consumidores idempotentes e filas de dead letter, por isso nenhum pedido se perde. A triagem é o fluxo assíncrono: o Reports publica o pedido e o worker chama o modelo local, Ollama com qwen3 de 4 mil milhões de parâmetros, através do WireMock, que também serve para simular falhas. A integração externa é a API de autocarros do Porto Digital, com o WireMock para testes e para a demo. Os dois modos degradados: sem IA, o pedido aparece como Não triado; sem transportes, mostramos os últimos dados válidos com aviso. Tudo corre localmente com Docker Compose, com autorização do professor por causa dos custos.</a:t>
+              <a:t>(~75 s) A arquitetura. Há uma única aplicação web em React, com páginas pensadas para o telemóvel ou para o portátil. Tudo entra pelo API gateway, que valida o token do Keycloak, aplica CORS e limites por conta. Atrás há cinco microserviços em Spring Boot, cada um com a sua base de dados PostgreSQL e o seu Dockerfile. Esta é a arquitetura alvo: hoje corre só o Reports, o walking skeleton, e o resto chega nos Sprints B e C. Os serviços não chamam a API uns dos outros: comunicam só por eventos no RabbitMQ, com tabela de outbox, consumidores idempotentes e filas de dead letter, por isso nenhum pedido se perde. A triagem é o fluxo assíncrono: o Reports publica o pedido e o worker chama o modelo local, Ollama com qwen3 de 4 mil milhões de parâmetros, através do WireMock, que também serve para simular falhas. A integração externa é a API de autocarros do Porto Digital, com o WireMock para testes e para a demo. Os dois modos degradados: sem IA, o pedido aparece como Não triado; sem transportes, mostramos os últimos dados válidos com aviso. Tudo corre localmente com Docker Compose, com autorização do professor por causa dos custos.</a:t>
             </a:r>
             <a:endParaRPr lang="en-US" dirty="0"/>
           </a:p>
@@ -7287,7 +7287,7 @@
                   <a:schemeClr val="tx1"/>
                 </a:solidFill>
               </a:rPr>
-              <a:t>Reports service: creates and reads synthetic help requests, with health check, HTTP tests, Dockerfile, Compose and CI smoke test</a:t>
+              <a:t>Reports service: creates and reads synthetic help requests in memory, with health check, HTTP tests, Dockerfile, Compose and CI smoke test</a:t>
             </a:r>
             <a:endParaRPr lang="en-US" sz="1200" dirty="0"/>
           </a:p>
@@ -9719,7 +9719,7 @@
                   <a:schemeClr val="tx1"/>
                 </a:solidFill>
               </a:rPr>
-              <a:t>Copilot review + one team approval</a:t>
+              <a:t>One team approval (Copilot also requested)</a:t>
             </a:r>
             <a:endParaRPr lang="en-US" sz="1300" dirty="0"/>
           </a:p>
@@ -14614,7 +14614,7 @@
                   <a:schemeClr val="tx1"/>
                 </a:solidFill>
               </a:rPr>
-              <a:t>Asks for help: category and her phone location, or a spot on the map (112 first)</a:t>
+              <a:t>Asks for help: category and her phone location, or a spot on the map</a:t>
             </a:r>
             <a:endParaRPr lang="en-US" sz="1200" dirty="0"/>
           </a:p>

</xml_diff>

<commit_message>
docs (#175): Phase the phone location of the help request
Team decision of 1 November 2026 (option c): survey decision 4 stays the
direction; Sprint B uses the map point and the phone's location comes in
Sprint C, after ADR-007 places a phone position on a map version and
assessment M-1 is amended. Applied to M-1, ADR-007, features F6/US-23 (and
issue #71), W2, personas and the report. The decks get slide 4 (phased) and
slide 9 (ADR-001 "from the start").

Co-Authored-By: Claude Opus 5.5 <noreply@anthropic.com>
</commit_message>
<xml_diff>
--- a/Docs/Presentation/Farol_Sprint_A_Presentation.pptx
+++ b/Docs/Presentation/Farol_Sprint_A_Presentation.pptx
@@ -1909,7 +1909,7 @@
           <a:p>
             <a:r>
               <a:rPr lang="en-US" dirty="0"/>
-              <a:t>(~60 s) Do inquérito tirámos cinco decisões. Duas confirmam o que já tínhamos: a planta é o centro da aplicação, e a IA fica na triagem dos pedidos de ajuda e não num chatbot para participantes, que quase ninguém escolheu. Três mudam o backlog: o estado das entradas por porta sobe de Could para Should, porque a espera é o problema mais comum; a bateria e a rede fraca passam a ser restrições de desenho, com páginas leves, e o modo de rede fraca volta a ser discutido; e no pedido de ajuda a aplicação pede a localização do telemóvel, que 71 % aceita partilhar, e quem recusar marca o sítio na planta. O pressuposto de que pedir ajuda pela app é mais rápido ainda não está validado: falta a entrevista ao voluntário de segurança.</a:t>
+              <a:t>(~60 s) Do inquérito tirámos cinco decisões. Duas confirmam o que já tínhamos: a planta é o centro da aplicação, e a IA fica na triagem dos pedidos de ajuda e não num chatbot para participantes, que quase ninguém escolheu. Três mudam o backlog: o estado das entradas por porta sobe de Could para Should, porque a espera é o problema mais comum; a bateria e a rede fraca passam a ser restrições de desenho, com páginas leves, e o modo de rede fraca volta a ser discutido; e no pedido de ajuda a aplicação vai pedir a localização do telemóvel, que 71 % aceita partilhar, com a planta como alternativa. Fazemo-lo por fases: no Sprint B o pedido usa o ponto na planta, e a localização do telemóvel entra no Sprint C, depois de sabermos colocar uma posição GPS na planta. O pressuposto de que pedir ajuda pela app é mais rápido ainda não está validado: falta a entrevista ao voluntário de segurança.</a:t>
             </a:r>
             <a:endParaRPr lang="en-US" dirty="0"/>
           </a:p>
@@ -12812,7 +12812,7 @@
                   <a:schemeClr val="tx2"/>
                 </a:solidFill>
               </a:rPr>
-              <a:t>Help: phone location first, map as fallback</a:t>
+              <a:t>Help: map now, phone location from Sprint C</a:t>
             </a:r>
             <a:endParaRPr lang="en-US" sz="1500" dirty="0"/>
           </a:p>
@@ -12906,7 +12906,7 @@
                   <a:schemeClr val="tx2"/>
                 </a:solidFill>
               </a:rPr>
-              <a:t>Decided</a:t>
+              <a:t>Phased</a:t>
             </a:r>
             <a:endParaRPr lang="en-US" sz="1100" dirty="0"/>
           </a:p>
@@ -20158,7 +20158,7 @@
                   <a:schemeClr val="bg1"/>
                 </a:solidFill>
               </a:rPr>
-              <a:t>001 Microservices from Sprint A</a:t>
+              <a:t>001 Microservices from the start</a:t>
             </a:r>
             <a:endParaRPr lang="en-US" sz="1100" dirty="0"/>
           </a:p>

</xml_diff>